<commit_message>
Final submission: ISOTHERM autonomous smart building control
</commit_message>
<xml_diff>
--- a/ISOTHERM_Hackathon_Presentation.pptx
+++ b/ISOTHERM_Hackathon_Presentation.pptx
@@ -5,15 +5,15 @@
     <p:sldMasterId id="2147483648" r:id="rId1"/>
   </p:sldMasterIdLst>
   <p:notesMasterIdLst>
-    <p:notesMasterId r:id="rId9"/>
+    <p:notesMasterId r:id="rId8"/>
   </p:notesMasterIdLst>
   <p:sldIdLst>
-    <p:sldId id="298" r:id="rId3"/>
-    <p:sldId id="281" r:id="rId4"/>
-    <p:sldId id="290" r:id="rId5"/>
-    <p:sldId id="293" r:id="rId6"/>
-    <p:sldId id="299" r:id="rId7"/>
-    <p:sldId id="296" r:id="rId8"/>
+    <p:sldId id="298" r:id="rId2"/>
+    <p:sldId id="281" r:id="rId3"/>
+    <p:sldId id="290" r:id="rId4"/>
+    <p:sldId id="293" r:id="rId5"/>
+    <p:sldId id="299" r:id="rId6"/>
+    <p:sldId id="296" r:id="rId7"/>
   </p:sldIdLst>
   <p:sldSz cx="12192000" cy="6858000"/>
   <p:notesSz cx="6858000" cy="9144000"/>
@@ -261,7 +261,7 @@
             <a:fld id="{C4D5ADD5-2BBC-4A94-8F86-D9013941F742}" type="datetimeFigureOut">
               <a:rPr lang="en-US"/>
               <a:pPr/>
-              <a:t>7/24/2026</a:t>
+              <a:t>7/26/2026</a:t>
             </a:fld>
             <a:endParaRPr lang="en-US"/>
           </a:p>
@@ -579,6 +579,125 @@
 </p:notesMaster>
 </file>
 
+<file path=ppt/notesSlides/notesSlide1.xml><?xml version="1.0" encoding="utf-8"?>
+<p:notes xmlns:a="http://schemas.openxmlformats.org/drawingml/2006/main" xmlns:r="http://schemas.openxmlformats.org/officeDocument/2006/relationships" xmlns:p="http://schemas.openxmlformats.org/presentationml/2006/main">
+  <p:cSld>
+    <p:spTree>
+      <p:nvGrpSpPr>
+        <p:cNvPr id="1" name=""/>
+        <p:cNvGrpSpPr/>
+        <p:nvPr/>
+      </p:nvGrpSpPr>
+      <p:grpSpPr>
+        <a:xfrm>
+          <a:off x="0" y="0"/>
+          <a:ext cx="0" cy="0"/>
+          <a:chOff x="0" y="0"/>
+          <a:chExt cx="0" cy="0"/>
+        </a:xfrm>
+      </p:grpSpPr>
+      <p:sp>
+        <p:nvSpPr>
+          <p:cNvPr id="16385" name="Slide Image Placeholder 1"/>
+          <p:cNvSpPr>
+            <a:spLocks noGrp="1" noRot="1" noChangeAspect="1"/>
+          </p:cNvSpPr>
+          <p:nvPr>
+            <p:ph type="sldImg"/>
+          </p:nvPr>
+        </p:nvSpPr>
+        <p:spPr bwMode="auto">
+          <a:xfrm>
+            <a:off x="381000" y="685800"/>
+            <a:ext cx="6096000" cy="3429000"/>
+          </a:xfrm>
+          <a:noFill/>
+          <a:ln>
+            <a:solidFill>
+              <a:srgbClr val="000000"/>
+            </a:solidFill>
+            <a:miter lim="800000"/>
+            <a:headEnd/>
+            <a:tailEnd/>
+          </a:ln>
+        </p:spPr>
+      </p:sp>
+      <p:sp>
+        <p:nvSpPr>
+          <p:cNvPr id="16386" name="Notes Placeholder 2"/>
+          <p:cNvSpPr>
+            <a:spLocks noGrp="1"/>
+          </p:cNvSpPr>
+          <p:nvPr>
+            <p:ph type="body" idx="1"/>
+          </p:nvPr>
+        </p:nvSpPr>
+        <p:spPr bwMode="auto">
+          <a:noFill/>
+        </p:spPr>
+        <p:txBody>
+          <a:bodyPr wrap="square" numCol="1" anchor="t" anchorCtr="0" compatLnSpc="1">
+            <a:prstTxWarp prst="textNoShape">
+              <a:avLst/>
+            </a:prstTxWarp>
+          </a:bodyPr>
+          <a:lstStyle/>
+          <a:p>
+            <a:pPr eaLnBrk="1" hangingPunct="1">
+              <a:spcBef>
+                <a:spcPct val="0"/>
+              </a:spcBef>
+            </a:pPr>
+            <a:endParaRPr lang="en-US">
+              <a:ea typeface="ＭＳ Ｐゴシック" pitchFamily="1" charset="-128"/>
+            </a:endParaRPr>
+          </a:p>
+        </p:txBody>
+      </p:sp>
+      <p:sp>
+        <p:nvSpPr>
+          <p:cNvPr id="16387" name="Slide Number Placeholder 3"/>
+          <p:cNvSpPr>
+            <a:spLocks noGrp="1"/>
+          </p:cNvSpPr>
+          <p:nvPr>
+            <p:ph type="sldNum" sz="quarter" idx="5"/>
+          </p:nvPr>
+        </p:nvSpPr>
+        <p:spPr bwMode="auto">
+          <a:noFill/>
+          <a:ln>
+            <a:miter lim="800000"/>
+            <a:headEnd/>
+            <a:tailEnd/>
+          </a:ln>
+        </p:spPr>
+        <p:txBody>
+          <a:bodyPr/>
+          <a:lstStyle/>
+          <a:p>
+            <a:fld id="{65F62A7E-A2F8-438F-9CF8-47DE63F471B4}" type="slidenum">
+              <a:rPr lang="en-US"/>
+              <a:pPr/>
+              <a:t>2</a:t>
+            </a:fld>
+            <a:endParaRPr lang="en-US"/>
+          </a:p>
+        </p:txBody>
+      </p:sp>
+    </p:spTree>
+    <p:extLst>
+      <p:ext uri="{BB962C8B-B14F-4D97-AF65-F5344CB8AC3E}">
+        <p14:creationId xmlns:p14="http://schemas.microsoft.com/office/powerpoint/2010/main" val="2904073229"/>
+      </p:ext>
+    </p:extLst>
+  </p:cSld>
+  <p:clrMapOvr>
+    <a:masterClrMapping/>
+  </p:clrMapOvr>
+</p:notes>
+</file>
+
 <file path=ppt/notesSlides/notesSlide2.xml><?xml version="1.0" encoding="utf-8"?>
 <p:notes xmlns:a="http://schemas.openxmlformats.org/drawingml/2006/main" xmlns:r="http://schemas.openxmlformats.org/officeDocument/2006/relationships" xmlns:p="http://schemas.openxmlformats.org/presentationml/2006/main">
   <p:cSld>
@@ -598,7 +717,7 @@
       </p:grpSpPr>
       <p:sp>
         <p:nvSpPr>
-          <p:cNvPr id="16385" name="Slide Image Placeholder 1"/>
+          <p:cNvPr id="18433" name="Slide Image Placeholder 1"/>
           <p:cNvSpPr>
             <a:spLocks noGrp="1" noRot="1" noChangeAspect="1"/>
           </p:cNvSpPr>
@@ -624,7 +743,7 @@
       </p:sp>
       <p:sp>
         <p:nvSpPr>
-          <p:cNvPr id="16386" name="Notes Placeholder 2"/>
+          <p:cNvPr id="18434" name="Notes Placeholder 2"/>
           <p:cNvSpPr>
             <a:spLocks noGrp="1"/>
           </p:cNvSpPr>
@@ -656,7 +775,7 @@
       </p:sp>
       <p:sp>
         <p:nvSpPr>
-          <p:cNvPr id="16387" name="Slide Number Placeholder 3"/>
+          <p:cNvPr id="18435" name="Slide Number Placeholder 3"/>
           <p:cNvSpPr>
             <a:spLocks noGrp="1"/>
           </p:cNvSpPr>
@@ -676,7 +795,7 @@
           <a:bodyPr/>
           <a:lstStyle/>
           <a:p>
-            <a:fld id="{65F62A7E-A2F8-438F-9CF8-47DE63F471B4}" type="slidenum">
+            <a:fld id="{0CA7B74D-3791-4AC6-8451-F10DBCCCDD9A}" type="slidenum">
               <a:rPr lang="en-US"/>
               <a:pPr/>
               <a:t>3</a:t>
@@ -688,7 +807,7 @@
     </p:spTree>
     <p:extLst>
       <p:ext uri="{BB962C8B-B14F-4D97-AF65-F5344CB8AC3E}">
-        <p14:creationId xmlns:p14="http://schemas.microsoft.com/office/powerpoint/2010/main" val="2904073229"/>
+        <p14:creationId xmlns:p14="http://schemas.microsoft.com/office/powerpoint/2010/main" val="2335206292"/>
       </p:ext>
     </p:extLst>
   </p:cSld>
@@ -795,19 +914,78 @@
           <a:bodyPr/>
           <a:lstStyle/>
           <a:p>
+            <a:pPr marL="0" marR="0" lvl="0" indent="0" algn="r" defTabSz="457200" rtl="0" eaLnBrk="1" fontAlgn="base" latinLnBrk="0" hangingPunct="1">
+              <a:lnSpc>
+                <a:spcPct val="100000"/>
+              </a:lnSpc>
+              <a:spcBef>
+                <a:spcPct val="0"/>
+              </a:spcBef>
+              <a:spcAft>
+                <a:spcPct val="0"/>
+              </a:spcAft>
+              <a:buClrTx/>
+              <a:buSzTx/>
+              <a:buFontTx/>
+              <a:buNone/>
+              <a:tabLst/>
+              <a:defRPr/>
+            </a:pPr>
             <a:fld id="{0CA7B74D-3791-4AC6-8451-F10DBCCCDD9A}" type="slidenum">
-              <a:rPr lang="en-US"/>
-              <a:pPr/>
+              <a:rPr kumimoji="0" lang="en-US" sz="1200" b="0" i="0" u="none" strike="noStrike" kern="1200" cap="none" spc="0" normalizeH="0" baseline="0" noProof="0">
+                <a:ln>
+                  <a:noFill/>
+                </a:ln>
+                <a:solidFill>
+                  <a:prstClr val="black"/>
+                </a:solidFill>
+                <a:effectLst/>
+                <a:uLnTx/>
+                <a:uFillTx/>
+                <a:latin typeface="Calibri" pitchFamily="34" charset="0"/>
+                <a:ea typeface="ＭＳ Ｐゴシック" pitchFamily="1" charset="-128"/>
+                <a:cs typeface="+mn-cs"/>
+              </a:rPr>
+              <a:pPr marL="0" marR="0" lvl="0" indent="0" algn="r" defTabSz="457200" rtl="0" eaLnBrk="1" fontAlgn="base" latinLnBrk="0" hangingPunct="1">
+                <a:lnSpc>
+                  <a:spcPct val="100000"/>
+                </a:lnSpc>
+                <a:spcBef>
+                  <a:spcPct val="0"/>
+                </a:spcBef>
+                <a:spcAft>
+                  <a:spcPct val="0"/>
+                </a:spcAft>
+                <a:buClrTx/>
+                <a:buSzTx/>
+                <a:buFontTx/>
+                <a:buNone/>
+                <a:tabLst/>
+                <a:defRPr/>
+              </a:pPr>
               <a:t>4</a:t>
             </a:fld>
-            <a:endParaRPr lang="en-US"/>
+            <a:endParaRPr kumimoji="0" lang="en-US" sz="1200" b="0" i="0" u="none" strike="noStrike" kern="1200" cap="none" spc="0" normalizeH="0" baseline="0" noProof="0">
+              <a:ln>
+                <a:noFill/>
+              </a:ln>
+              <a:solidFill>
+                <a:prstClr val="black"/>
+              </a:solidFill>
+              <a:effectLst/>
+              <a:uLnTx/>
+              <a:uFillTx/>
+              <a:latin typeface="Calibri" pitchFamily="34" charset="0"/>
+              <a:ea typeface="ＭＳ Ｐゴシック" pitchFamily="1" charset="-128"/>
+              <a:cs typeface="+mn-cs"/>
+            </a:endParaRPr>
           </a:p>
         </p:txBody>
       </p:sp>
     </p:spTree>
     <p:extLst>
       <p:ext uri="{BB962C8B-B14F-4D97-AF65-F5344CB8AC3E}">
-        <p14:creationId xmlns:p14="http://schemas.microsoft.com/office/powerpoint/2010/main" val="2335206292"/>
+        <p14:creationId xmlns:p14="http://schemas.microsoft.com/office/powerpoint/2010/main" val="3773505461"/>
       </p:ext>
     </p:extLst>
   </p:cSld>
@@ -822,7 +1000,13 @@
   <p:cSld>
     <p:spTree>
       <p:nvGrpSpPr>
-        <p:cNvPr id="1" name=""/>
+        <p:cNvPr id="1" name="">
+          <a:extLst>
+            <a:ext uri="{FF2B5EF4-FFF2-40B4-BE49-F238E27FC236}">
+              <a16:creationId xmlns:a16="http://schemas.microsoft.com/office/drawing/2014/main" id="{9949F277-D966-5891-8E8E-FE1852E6B425}"/>
+            </a:ext>
+          </a:extLst>
+        </p:cNvPr>
         <p:cNvGrpSpPr/>
         <p:nvPr/>
       </p:nvGrpSpPr>
@@ -836,7 +1020,13 @@
       </p:grpSpPr>
       <p:sp>
         <p:nvSpPr>
-          <p:cNvPr id="18433" name="Slide Image Placeholder 1"/>
+          <p:cNvPr id="18433" name="Slide Image Placeholder 1">
+            <a:extLst>
+              <a:ext uri="{FF2B5EF4-FFF2-40B4-BE49-F238E27FC236}">
+                <a16:creationId xmlns:a16="http://schemas.microsoft.com/office/drawing/2014/main" id="{63166A99-EAE2-2E28-993F-D5871297B24D}"/>
+              </a:ext>
+            </a:extLst>
+          </p:cNvPr>
           <p:cNvSpPr>
             <a:spLocks noGrp="1" noRot="1" noChangeAspect="1"/>
           </p:cNvSpPr>
@@ -862,7 +1052,13 @@
       </p:sp>
       <p:sp>
         <p:nvSpPr>
-          <p:cNvPr id="18434" name="Notes Placeholder 2"/>
+          <p:cNvPr id="18434" name="Notes Placeholder 2">
+            <a:extLst>
+              <a:ext uri="{FF2B5EF4-FFF2-40B4-BE49-F238E27FC236}">
+                <a16:creationId xmlns:a16="http://schemas.microsoft.com/office/drawing/2014/main" id="{4ED88F3D-7791-59C8-716F-0AAD4C669A9A}"/>
+              </a:ext>
+            </a:extLst>
+          </p:cNvPr>
           <p:cNvSpPr>
             <a:spLocks noGrp="1"/>
           </p:cNvSpPr>
@@ -894,7 +1090,13 @@
       </p:sp>
       <p:sp>
         <p:nvSpPr>
-          <p:cNvPr id="18435" name="Slide Number Placeholder 3"/>
+          <p:cNvPr id="18435" name="Slide Number Placeholder 3">
+            <a:extLst>
+              <a:ext uri="{FF2B5EF4-FFF2-40B4-BE49-F238E27FC236}">
+                <a16:creationId xmlns:a16="http://schemas.microsoft.com/office/drawing/2014/main" id="{CC82298B-112C-33CB-5F98-D6F1C4A4C6DE}"/>
+              </a:ext>
+            </a:extLst>
+          </p:cNvPr>
           <p:cNvSpPr>
             <a:spLocks noGrp="1"/>
           </p:cNvSpPr>
@@ -985,7 +1187,7 @@
     </p:spTree>
     <p:extLst>
       <p:ext uri="{BB962C8B-B14F-4D97-AF65-F5344CB8AC3E}">
-        <p14:creationId xmlns:p14="http://schemas.microsoft.com/office/powerpoint/2010/main" val="3773505461"/>
+        <p14:creationId xmlns:p14="http://schemas.microsoft.com/office/powerpoint/2010/main" val="4173051335"/>
       </p:ext>
     </p:extLst>
   </p:cSld>
@@ -1000,13 +1202,7 @@
   <p:cSld>
     <p:spTree>
       <p:nvGrpSpPr>
-        <p:cNvPr id="1" name="">
-          <a:extLst>
-            <a:ext uri="{FF2B5EF4-FFF2-40B4-BE49-F238E27FC236}">
-              <a16:creationId xmlns:a16="http://schemas.microsoft.com/office/drawing/2014/main" id="{9949F277-D966-5891-8E8E-FE1852E6B425}"/>
-            </a:ext>
-          </a:extLst>
-        </p:cNvPr>
+        <p:cNvPr id="1" name=""/>
         <p:cNvGrpSpPr/>
         <p:nvPr/>
       </p:nvGrpSpPr>
@@ -1020,13 +1216,7 @@
       </p:grpSpPr>
       <p:sp>
         <p:nvSpPr>
-          <p:cNvPr id="18433" name="Slide Image Placeholder 1">
-            <a:extLst>
-              <a:ext uri="{FF2B5EF4-FFF2-40B4-BE49-F238E27FC236}">
-                <a16:creationId xmlns:a16="http://schemas.microsoft.com/office/drawing/2014/main" id="{63166A99-EAE2-2E28-993F-D5871297B24D}"/>
-              </a:ext>
-            </a:extLst>
-          </p:cNvPr>
+          <p:cNvPr id="18433" name="Slide Image Placeholder 1"/>
           <p:cNvSpPr>
             <a:spLocks noGrp="1" noRot="1" noChangeAspect="1"/>
           </p:cNvSpPr>
@@ -1052,13 +1242,7 @@
       </p:sp>
       <p:sp>
         <p:nvSpPr>
-          <p:cNvPr id="18434" name="Notes Placeholder 2">
-            <a:extLst>
-              <a:ext uri="{FF2B5EF4-FFF2-40B4-BE49-F238E27FC236}">
-                <a16:creationId xmlns:a16="http://schemas.microsoft.com/office/drawing/2014/main" id="{4ED88F3D-7791-59C8-716F-0AAD4C669A9A}"/>
-              </a:ext>
-            </a:extLst>
-          </p:cNvPr>
+          <p:cNvPr id="18434" name="Notes Placeholder 2"/>
           <p:cNvSpPr>
             <a:spLocks noGrp="1"/>
           </p:cNvSpPr>
@@ -1090,13 +1274,7 @@
       </p:sp>
       <p:sp>
         <p:nvSpPr>
-          <p:cNvPr id="18435" name="Slide Number Placeholder 3">
-            <a:extLst>
-              <a:ext uri="{FF2B5EF4-FFF2-40B4-BE49-F238E27FC236}">
-                <a16:creationId xmlns:a16="http://schemas.microsoft.com/office/drawing/2014/main" id="{CC82298B-112C-33CB-5F98-D6F1C4A4C6DE}"/>
-              </a:ext>
-            </a:extLst>
-          </p:cNvPr>
+          <p:cNvPr id="18435" name="Slide Number Placeholder 3"/>
           <p:cNvSpPr>
             <a:spLocks noGrp="1"/>
           </p:cNvSpPr>
@@ -1187,184 +1365,6 @@
     </p:spTree>
     <p:extLst>
       <p:ext uri="{BB962C8B-B14F-4D97-AF65-F5344CB8AC3E}">
-        <p14:creationId xmlns:p14="http://schemas.microsoft.com/office/powerpoint/2010/main" val="4173051335"/>
-      </p:ext>
-    </p:extLst>
-  </p:cSld>
-  <p:clrMapOvr>
-    <a:masterClrMapping/>
-  </p:clrMapOvr>
-</p:notes>
-</file>
-
-<file path=ppt/notesSlides/notesSlide6.xml><?xml version="1.0" encoding="utf-8"?>
-<p:notes xmlns:a="http://schemas.openxmlformats.org/drawingml/2006/main" xmlns:r="http://schemas.openxmlformats.org/officeDocument/2006/relationships" xmlns:p="http://schemas.openxmlformats.org/presentationml/2006/main">
-  <p:cSld>
-    <p:spTree>
-      <p:nvGrpSpPr>
-        <p:cNvPr id="1" name=""/>
-        <p:cNvGrpSpPr/>
-        <p:nvPr/>
-      </p:nvGrpSpPr>
-      <p:grpSpPr>
-        <a:xfrm>
-          <a:off x="0" y="0"/>
-          <a:ext cx="0" cy="0"/>
-          <a:chOff x="0" y="0"/>
-          <a:chExt cx="0" cy="0"/>
-        </a:xfrm>
-      </p:grpSpPr>
-      <p:sp>
-        <p:nvSpPr>
-          <p:cNvPr id="18433" name="Slide Image Placeholder 1"/>
-          <p:cNvSpPr>
-            <a:spLocks noGrp="1" noRot="1" noChangeAspect="1"/>
-          </p:cNvSpPr>
-          <p:nvPr>
-            <p:ph type="sldImg"/>
-          </p:nvPr>
-        </p:nvSpPr>
-        <p:spPr bwMode="auto">
-          <a:xfrm>
-            <a:off x="381000" y="685800"/>
-            <a:ext cx="6096000" cy="3429000"/>
-          </a:xfrm>
-          <a:noFill/>
-          <a:ln>
-            <a:solidFill>
-              <a:srgbClr val="000000"/>
-            </a:solidFill>
-            <a:miter lim="800000"/>
-            <a:headEnd/>
-            <a:tailEnd/>
-          </a:ln>
-        </p:spPr>
-      </p:sp>
-      <p:sp>
-        <p:nvSpPr>
-          <p:cNvPr id="18434" name="Notes Placeholder 2"/>
-          <p:cNvSpPr>
-            <a:spLocks noGrp="1"/>
-          </p:cNvSpPr>
-          <p:nvPr>
-            <p:ph type="body" idx="1"/>
-          </p:nvPr>
-        </p:nvSpPr>
-        <p:spPr bwMode="auto">
-          <a:noFill/>
-        </p:spPr>
-        <p:txBody>
-          <a:bodyPr wrap="square" numCol="1" anchor="t" anchorCtr="0" compatLnSpc="1">
-            <a:prstTxWarp prst="textNoShape">
-              <a:avLst/>
-            </a:prstTxWarp>
-          </a:bodyPr>
-          <a:lstStyle/>
-          <a:p>
-            <a:pPr eaLnBrk="1" hangingPunct="1">
-              <a:spcBef>
-                <a:spcPct val="0"/>
-              </a:spcBef>
-            </a:pPr>
-            <a:endParaRPr lang="en-US">
-              <a:ea typeface="ＭＳ Ｐゴシック" pitchFamily="1" charset="-128"/>
-            </a:endParaRPr>
-          </a:p>
-        </p:txBody>
-      </p:sp>
-      <p:sp>
-        <p:nvSpPr>
-          <p:cNvPr id="18435" name="Slide Number Placeholder 3"/>
-          <p:cNvSpPr>
-            <a:spLocks noGrp="1"/>
-          </p:cNvSpPr>
-          <p:nvPr>
-            <p:ph type="sldNum" sz="quarter" idx="5"/>
-          </p:nvPr>
-        </p:nvSpPr>
-        <p:spPr bwMode="auto">
-          <a:noFill/>
-          <a:ln>
-            <a:miter lim="800000"/>
-            <a:headEnd/>
-            <a:tailEnd/>
-          </a:ln>
-        </p:spPr>
-        <p:txBody>
-          <a:bodyPr/>
-          <a:lstStyle/>
-          <a:p>
-            <a:pPr marL="0" marR="0" lvl="0" indent="0" algn="r" defTabSz="457200" rtl="0" eaLnBrk="1" fontAlgn="base" latinLnBrk="0" hangingPunct="1">
-              <a:lnSpc>
-                <a:spcPct val="100000"/>
-              </a:lnSpc>
-              <a:spcBef>
-                <a:spcPct val="0"/>
-              </a:spcBef>
-              <a:spcAft>
-                <a:spcPct val="0"/>
-              </a:spcAft>
-              <a:buClrTx/>
-              <a:buSzTx/>
-              <a:buFontTx/>
-              <a:buNone/>
-              <a:tabLst/>
-              <a:defRPr/>
-            </a:pPr>
-            <a:fld id="{0CA7B74D-3791-4AC6-8451-F10DBCCCDD9A}" type="slidenum">
-              <a:rPr kumimoji="0" lang="en-US" sz="1200" b="0" i="0" u="none" strike="noStrike" kern="1200" cap="none" spc="0" normalizeH="0" baseline="0" noProof="0">
-                <a:ln>
-                  <a:noFill/>
-                </a:ln>
-                <a:solidFill>
-                  <a:prstClr val="black"/>
-                </a:solidFill>
-                <a:effectLst/>
-                <a:uLnTx/>
-                <a:uFillTx/>
-                <a:latin typeface="Calibri" pitchFamily="34" charset="0"/>
-                <a:ea typeface="ＭＳ Ｐゴシック" pitchFamily="1" charset="-128"/>
-                <a:cs typeface="+mn-cs"/>
-              </a:rPr>
-              <a:pPr marL="0" marR="0" lvl="0" indent="0" algn="r" defTabSz="457200" rtl="0" eaLnBrk="1" fontAlgn="base" latinLnBrk="0" hangingPunct="1">
-                <a:lnSpc>
-                  <a:spcPct val="100000"/>
-                </a:lnSpc>
-                <a:spcBef>
-                  <a:spcPct val="0"/>
-                </a:spcBef>
-                <a:spcAft>
-                  <a:spcPct val="0"/>
-                </a:spcAft>
-                <a:buClrTx/>
-                <a:buSzTx/>
-                <a:buFontTx/>
-                <a:buNone/>
-                <a:tabLst/>
-                <a:defRPr/>
-              </a:pPr>
-              <a:t>7</a:t>
-            </a:fld>
-            <a:endParaRPr kumimoji="0" lang="en-US" sz="1200" b="0" i="0" u="none" strike="noStrike" kern="1200" cap="none" spc="0" normalizeH="0" baseline="0" noProof="0">
-              <a:ln>
-                <a:noFill/>
-              </a:ln>
-              <a:solidFill>
-                <a:prstClr val="black"/>
-              </a:solidFill>
-              <a:effectLst/>
-              <a:uLnTx/>
-              <a:uFillTx/>
-              <a:latin typeface="Calibri" pitchFamily="34" charset="0"/>
-              <a:ea typeface="ＭＳ Ｐゴシック" pitchFamily="1" charset="-128"/>
-              <a:cs typeface="+mn-cs"/>
-            </a:endParaRPr>
-          </a:p>
-        </p:txBody>
-      </p:sp>
-    </p:spTree>
-    <p:extLst>
-      <p:ext uri="{BB962C8B-B14F-4D97-AF65-F5344CB8AC3E}">
         <p14:creationId xmlns:p14="http://schemas.microsoft.com/office/powerpoint/2010/main" val="1908672725"/>
       </p:ext>
     </p:extLst>
@@ -1558,7 +1558,7 @@
           <a:p>
             <a:fld id="{E60792E3-D524-454C-8AFD-A91972900BCB}" type="datetime1">
               <a:rPr lang="en-US" smtClean="0"/>
-              <a:t>7/24/2026</a:t>
+              <a:t>7/26/2026</a:t>
             </a:fld>
             <a:endParaRPr lang="en-US"/>
           </a:p>
@@ -1740,7 +1740,7 @@
           <a:p>
             <a:fld id="{053C3A68-6922-42D3-8905-ECC2D82A3469}" type="datetime1">
               <a:rPr lang="en-US" smtClean="0"/>
-              <a:t>7/24/2026</a:t>
+              <a:t>7/26/2026</a:t>
             </a:fld>
             <a:endParaRPr lang="en-US"/>
           </a:p>
@@ -1932,7 +1932,7 @@
           <a:p>
             <a:fld id="{CB69E9F4-7604-4950-A8B2-8ACDEDB1506E}" type="datetime1">
               <a:rPr lang="en-US" smtClean="0"/>
-              <a:t>7/24/2026</a:t>
+              <a:t>7/26/2026</a:t>
             </a:fld>
             <a:endParaRPr lang="en-US"/>
           </a:p>
@@ -2114,7 +2114,7 @@
           <a:p>
             <a:fld id="{708B7524-32A2-4C20-A58C-BC3BAA1042FC}" type="datetime1">
               <a:rPr lang="en-US" smtClean="0"/>
-              <a:t>7/24/2026</a:t>
+              <a:t>7/26/2026</a:t>
             </a:fld>
             <a:endParaRPr lang="en-US"/>
           </a:p>
@@ -2373,7 +2373,7 @@
           <a:p>
             <a:fld id="{1E994447-D6B2-43BB-A877-57F1A267B999}" type="datetime1">
               <a:rPr lang="en-US" smtClean="0"/>
-              <a:t>7/24/2026</a:t>
+              <a:t>7/26/2026</a:t>
             </a:fld>
             <a:endParaRPr lang="en-US"/>
           </a:p>
@@ -2672,7 +2672,7 @@
           <a:p>
             <a:fld id="{68920E16-BD35-483C-AA6B-346FC7E46DEA}" type="datetime1">
               <a:rPr lang="en-US" smtClean="0"/>
-              <a:t>7/24/2026</a:t>
+              <a:t>7/26/2026</a:t>
             </a:fld>
             <a:endParaRPr lang="en-US"/>
           </a:p>
@@ -3105,7 +3105,7 @@
           <a:p>
             <a:fld id="{2FEAC6F8-5103-4FC0-A69E-5C6AE6469DA8}" type="datetime1">
               <a:rPr lang="en-US" smtClean="0"/>
-              <a:t>7/24/2026</a:t>
+              <a:t>7/26/2026</a:t>
             </a:fld>
             <a:endParaRPr lang="en-US"/>
           </a:p>
@@ -3236,7 +3236,7 @@
           <a:p>
             <a:fld id="{C60C6921-0627-4C8F-83D5-0CF936D2FFDD}" type="datetime1">
               <a:rPr lang="en-US" smtClean="0"/>
-              <a:t>7/24/2026</a:t>
+              <a:t>7/26/2026</a:t>
             </a:fld>
             <a:endParaRPr lang="en-US"/>
           </a:p>
@@ -3345,7 +3345,7 @@
           <a:p>
             <a:fld id="{2FF08AD7-8103-40F8-983C-E2BA6BB9CBE0}" type="datetime1">
               <a:rPr lang="en-US" smtClean="0"/>
-              <a:t>7/24/2026</a:t>
+              <a:t>7/26/2026</a:t>
             </a:fld>
             <a:endParaRPr lang="en-US"/>
           </a:p>
@@ -3634,7 +3634,7 @@
           <a:p>
             <a:fld id="{DF8C06B4-9380-4A4D-AF49-A3596E17DAF5}" type="datetime1">
               <a:rPr lang="en-US" smtClean="0"/>
-              <a:t>7/24/2026</a:t>
+              <a:t>7/26/2026</a:t>
             </a:fld>
             <a:endParaRPr lang="en-US"/>
           </a:p>
@@ -3903,7 +3903,7 @@
           <a:p>
             <a:fld id="{EF7FDEF1-C582-4E22-9E77-D68326471F28}" type="datetime1">
               <a:rPr lang="en-US" smtClean="0"/>
-              <a:t>7/24/2026</a:t>
+              <a:t>7/26/2026</a:t>
             </a:fld>
             <a:endParaRPr lang="en-US"/>
           </a:p>
@@ -4146,7 +4146,7 @@
           <a:p>
             <a:fld id="{780A9602-A9A9-453F-AEF1-37B5837E02CD}" type="datetime1">
               <a:rPr lang="en-US" smtClean="0"/>
-              <a:t>7/24/2026</a:t>
+              <a:t>7/26/2026</a:t>
             </a:fld>
             <a:endParaRPr lang="en-US"/>
           </a:p>
@@ -4664,7 +4664,7 @@
 </p:sldMaster>
 </file>
 
-<file path=ppt/slides/slide2.xml><?xml version="1.0" encoding="utf-8"?>
+<file path=ppt/slides/slide1.xml><?xml version="1.0" encoding="utf-8"?>
 <p:sld xmlns:a="http://schemas.openxmlformats.org/drawingml/2006/main" xmlns:r="http://schemas.openxmlformats.org/officeDocument/2006/relationships" xmlns:p="http://schemas.openxmlformats.org/presentationml/2006/main">
   <p:cSld>
     <p:spTree>
@@ -4736,7 +4736,7 @@
             <a:fld id="{677C3CE7-23F7-4828-823C-E0205DF2CF97}" type="slidenum">
               <a:rPr lang="en-US" smtClean="0"/>
               <a:pPr/>
-              <a:t>2</a:t>
+              <a:t>1</a:t>
             </a:fld>
             <a:endParaRPr lang="en-US"/>
           </a:p>
@@ -4980,10 +4980,10 @@
       </p:sp>
       <p:sp>
         <p:nvSpPr>
-          <p:cNvPr id="7" name="TextBox 6">
+          <p:cNvPr id="3" name="TextBox 2">
             <a:extLst>
               <a:ext uri="{FF2B5EF4-FFF2-40B4-BE49-F238E27FC236}">
-                <a16:creationId xmlns:a16="http://schemas.microsoft.com/office/drawing/2014/main" id="{AFB1BDE7-2DA0-F526-CF6E-F50D43C2C5FE}"/>
+                <a16:creationId xmlns:a16="http://schemas.microsoft.com/office/drawing/2014/main" id="{7C19C992-F871-8F62-9E59-574D7119AE3E}"/>
               </a:ext>
             </a:extLst>
           </p:cNvPr>
@@ -4992,8 +4992,8 @@
         </p:nvSpPr>
         <p:spPr>
           <a:xfrm>
-            <a:off x="731520" y="1371600"/>
-            <a:ext cx="10698480" cy="4572000"/>
+            <a:off x="1036066" y="754935"/>
+            <a:ext cx="10293350" cy="4686668"/>
           </a:xfrm>
           <a:prstGeom prst="rect">
             <a:avLst/>
@@ -5001,7 +5001,271 @@
           <a:noFill/>
         </p:spPr>
         <p:txBody>
-          <a:bodyPr wrap="square" rtlCol="0">
+          <a:bodyPr wrap="square">
+            <a:spAutoFit/>
+          </a:bodyPr>
+          <a:lstStyle/>
+          <a:p>
+            <a:endParaRPr lang="en-US" dirty="0"/>
+          </a:p>
+          <a:p>
+            <a:pPr marL="285750" indent="-285750" algn="just">
+              <a:lnSpc>
+                <a:spcPct val="200000"/>
+              </a:lnSpc>
+              <a:buFont typeface="Arial" panose="020B0604020202020204" pitchFamily="34" charset="0"/>
+              <a:buChar char="•"/>
+            </a:pPr>
+            <a:r>
+              <a:rPr lang="en-US" sz="2400" b="1" dirty="0">
+                <a:latin typeface="Arial" panose="020B0604020202020204" pitchFamily="34" charset="0"/>
+                <a:cs typeface="Arial" panose="020B0604020202020204" pitchFamily="34" charset="0"/>
+              </a:rPr>
+              <a:t>Problem Statement ID –01</a:t>
+            </a:r>
+          </a:p>
+          <a:p>
+            <a:pPr marL="285750" indent="-285750" algn="just">
+              <a:lnSpc>
+                <a:spcPct val="200000"/>
+              </a:lnSpc>
+              <a:buFont typeface="Arial" panose="020B0604020202020204" pitchFamily="34" charset="0"/>
+              <a:buChar char="•"/>
+            </a:pPr>
+            <a:r>
+              <a:rPr lang="en-US" sz="2400" b="1" dirty="0">
+                <a:latin typeface="Arial" panose="020B0604020202020204" pitchFamily="34" charset="0"/>
+                <a:cs typeface="Arial" panose="020B0604020202020204" pitchFamily="34" charset="0"/>
+              </a:rPr>
+              <a:t>Problem Statement Title</a:t>
+            </a:r>
+            <a:r>
+              <a:rPr lang="en-US" sz="2400" dirty="0">
+                <a:latin typeface="Arial" panose="020B0604020202020204" pitchFamily="34" charset="0"/>
+                <a:cs typeface="Arial" panose="020B0604020202020204" pitchFamily="34" charset="0"/>
+              </a:rPr>
+              <a:t>- </a:t>
+            </a:r>
+            <a:r>
+              <a:rPr lang="en-US" sz="2400" b="1" dirty="0">
+                <a:latin typeface="Arial" panose="020B0604020202020204" pitchFamily="34" charset="0"/>
+                <a:cs typeface="Arial" panose="020B0604020202020204" pitchFamily="34" charset="0"/>
+              </a:rPr>
+              <a:t>ISOTHERM</a:t>
+            </a:r>
+            <a:r>
+              <a:rPr lang="en-US" sz="2400" dirty="0">
+                <a:latin typeface="Arial" panose="020B0604020202020204" pitchFamily="34" charset="0"/>
+                <a:cs typeface="Arial" panose="020B0604020202020204" pitchFamily="34" charset="0"/>
+              </a:rPr>
+              <a:t>- Eco-Loop Building Agents</a:t>
+            </a:r>
+          </a:p>
+          <a:p>
+            <a:pPr marL="285750" indent="-285750" algn="just">
+              <a:lnSpc>
+                <a:spcPct val="200000"/>
+              </a:lnSpc>
+              <a:buFont typeface="Arial" panose="020B0604020202020204" pitchFamily="34" charset="0"/>
+              <a:buChar char="•"/>
+            </a:pPr>
+            <a:r>
+              <a:rPr lang="en-US" sz="2400" b="1" dirty="0">
+                <a:latin typeface="Arial" panose="020B0604020202020204" pitchFamily="34" charset="0"/>
+                <a:cs typeface="Arial" panose="020B0604020202020204" pitchFamily="34" charset="0"/>
+              </a:rPr>
+              <a:t>Theme-</a:t>
+            </a:r>
+            <a:r>
+              <a:rPr lang="en-IN" sz="2400" b="1" dirty="0">
+                <a:latin typeface="Arial" panose="020B0604020202020204" pitchFamily="34" charset="0"/>
+                <a:cs typeface="Arial" panose="020B0604020202020204" pitchFamily="34" charset="0"/>
+              </a:rPr>
+              <a:t> </a:t>
+            </a:r>
+            <a:r>
+              <a:rPr lang="en-IN" sz="2400" dirty="0"/>
+              <a:t>AI-Powered Autonomous Smart Building Optimization Challenge</a:t>
+            </a:r>
+            <a:endParaRPr lang="en-US" sz="2400" dirty="0">
+              <a:latin typeface="Arial" panose="020B0604020202020204" pitchFamily="34" charset="0"/>
+              <a:cs typeface="Arial" panose="020B0604020202020204" pitchFamily="34" charset="0"/>
+            </a:endParaRPr>
+          </a:p>
+          <a:p>
+            <a:pPr marL="285750" indent="-285750" algn="just">
+              <a:lnSpc>
+                <a:spcPct val="200000"/>
+              </a:lnSpc>
+              <a:buFont typeface="Arial" panose="020B0604020202020204" pitchFamily="34" charset="0"/>
+              <a:buChar char="•"/>
+            </a:pPr>
+            <a:r>
+              <a:rPr lang="en-US" sz="2400" b="1" dirty="0">
+                <a:latin typeface="Arial" panose="020B0604020202020204" pitchFamily="34" charset="0"/>
+                <a:cs typeface="Arial" panose="020B0604020202020204" pitchFamily="34" charset="0"/>
+              </a:rPr>
+              <a:t>PS Category- </a:t>
+            </a:r>
+            <a:r>
+              <a:rPr lang="en-US" sz="2400" dirty="0">
+                <a:latin typeface="Arial" panose="020B0604020202020204" pitchFamily="34" charset="0"/>
+                <a:cs typeface="Arial" panose="020B0604020202020204" pitchFamily="34" charset="0"/>
+              </a:rPr>
+              <a:t>Software</a:t>
+            </a:r>
+          </a:p>
+          <a:p>
+            <a:pPr marL="285750" indent="-285750" algn="just">
+              <a:lnSpc>
+                <a:spcPct val="200000"/>
+              </a:lnSpc>
+              <a:buFont typeface="Arial" panose="020B0604020202020204" pitchFamily="34" charset="0"/>
+              <a:buChar char="•"/>
+            </a:pPr>
+            <a:r>
+              <a:rPr lang="en-US" sz="2400" b="1" dirty="0">
+                <a:latin typeface="Arial" panose="020B0604020202020204" pitchFamily="34" charset="0"/>
+                <a:cs typeface="Arial" panose="020B0604020202020204" pitchFamily="34" charset="0"/>
+              </a:rPr>
+              <a:t>Student Name – </a:t>
+            </a:r>
+            <a:r>
+              <a:rPr lang="en-US" sz="2400" dirty="0">
+                <a:latin typeface="Arial" panose="020B0604020202020204" pitchFamily="34" charset="0"/>
+                <a:cs typeface="Arial" panose="020B0604020202020204" pitchFamily="34" charset="0"/>
+              </a:rPr>
+              <a:t>Aanidhya Patidar</a:t>
+            </a:r>
+            <a:endParaRPr lang="en-US" sz="2400" b="1" dirty="0">
+              <a:latin typeface="Arial" panose="020B0604020202020204" pitchFamily="34" charset="0"/>
+              <a:cs typeface="Arial" panose="020B0604020202020204" pitchFamily="34" charset="0"/>
+            </a:endParaRPr>
+          </a:p>
+          <a:p>
+            <a:pPr marL="285750" indent="-285750" algn="just">
+              <a:lnSpc>
+                <a:spcPct val="200000"/>
+              </a:lnSpc>
+              <a:buFont typeface="Arial" panose="020B0604020202020204" pitchFamily="34" charset="0"/>
+              <a:buChar char="•"/>
+            </a:pPr>
+            <a:r>
+              <a:rPr lang="en-US" sz="2400" b="1" dirty="0">
+                <a:latin typeface="Arial" panose="020B0604020202020204" pitchFamily="34" charset="0"/>
+                <a:cs typeface="Arial" panose="020B0604020202020204" pitchFamily="34" charset="0"/>
+              </a:rPr>
+              <a:t>Student ID – </a:t>
+            </a:r>
+            <a:r>
+              <a:rPr lang="en-US" sz="2400" dirty="0">
+                <a:latin typeface="Arial" panose="020B0604020202020204" pitchFamily="34" charset="0"/>
+                <a:cs typeface="Arial" panose="020B0604020202020204" pitchFamily="34" charset="0"/>
+              </a:rPr>
+              <a:t>23BAI10642</a:t>
+            </a:r>
+            <a:endParaRPr lang="en-IN" sz="2400" b="1" dirty="0">
+              <a:latin typeface="Arial" panose="020B0604020202020204" pitchFamily="34" charset="0"/>
+              <a:cs typeface="Arial" panose="020B0604020202020204" pitchFamily="34" charset="0"/>
+            </a:endParaRPr>
+          </a:p>
+        </p:txBody>
+      </p:sp>
+    </p:spTree>
+    <p:extLst>
+      <p:ext uri="{BB962C8B-B14F-4D97-AF65-F5344CB8AC3E}">
+        <p14:creationId xmlns:p14="http://schemas.microsoft.com/office/powerpoint/2010/main" val="3319884780"/>
+      </p:ext>
+    </p:extLst>
+  </p:cSld>
+  <p:clrMapOvr>
+    <a:masterClrMapping/>
+  </p:clrMapOvr>
+</p:sld>
+</file>
+
+<file path=ppt/slides/slide2.xml><?xml version="1.0" encoding="utf-8"?>
+<p:sld xmlns:a="http://schemas.openxmlformats.org/drawingml/2006/main" xmlns:r="http://schemas.openxmlformats.org/officeDocument/2006/relationships" xmlns:p="http://schemas.openxmlformats.org/presentationml/2006/main">
+  <p:cSld>
+    <p:spTree>
+      <p:nvGrpSpPr>
+        <p:cNvPr id="1" name=""/>
+        <p:cNvGrpSpPr/>
+        <p:nvPr/>
+      </p:nvGrpSpPr>
+      <p:grpSpPr>
+        <a:xfrm>
+          <a:off x="0" y="0"/>
+          <a:ext cx="0" cy="0"/>
+          <a:chOff x="0" y="0"/>
+          <a:chExt cx="0" cy="0"/>
+        </a:xfrm>
+      </p:grpSpPr>
+      <p:sp>
+        <p:nvSpPr>
+          <p:cNvPr id="15361" name="Title 1"/>
+          <p:cNvSpPr>
+            <a:spLocks noGrp="1"/>
+          </p:cNvSpPr>
+          <p:nvPr>
+            <p:ph type="title"/>
+          </p:nvPr>
+        </p:nvSpPr>
+        <p:spPr>
+          <a:xfrm>
+            <a:off x="182998" y="0"/>
+            <a:ext cx="10972800" cy="1143000"/>
+          </a:xfrm>
+        </p:spPr>
+        <p:txBody>
+          <a:bodyPr/>
+          <a:lstStyle/>
+          <a:p>
+            <a:pPr eaLnBrk="1" hangingPunct="1"/>
+            <a:br>
+              <a:rPr lang="en-US" sz="3600" b="1" dirty="0">
+                <a:latin typeface="Times New Roman" panose="02020603050405020304" pitchFamily="18" charset="0"/>
+                <a:ea typeface="ＭＳ Ｐゴシック" pitchFamily="1" charset="-128"/>
+                <a:cs typeface="Times New Roman" panose="02020603050405020304" pitchFamily="18" charset="0"/>
+              </a:rPr>
+            </a:br>
+            <a:r>
+              <a:rPr lang="en-US" sz="3600" b="1" dirty="0">
+                <a:latin typeface="Times New Roman" panose="02020603050405020304" pitchFamily="18" charset="0"/>
+                <a:ea typeface="ＭＳ Ｐゴシック" pitchFamily="1" charset="-128"/>
+                <a:cs typeface="Times New Roman" panose="02020603050405020304" pitchFamily="18" charset="0"/>
+              </a:rPr>
+              <a:t>IDEA TITLE</a:t>
+            </a:r>
+          </a:p>
+        </p:txBody>
+      </p:sp>
+      <p:sp>
+        <p:nvSpPr>
+          <p:cNvPr id="15362" name="TextBox 8"/>
+          <p:cNvSpPr txBox="1">
+            <a:spLocks noChangeArrowheads="1"/>
+          </p:cNvSpPr>
+          <p:nvPr/>
+        </p:nvSpPr>
+        <p:spPr bwMode="auto">
+          <a:xfrm>
+            <a:off x="883920" y="1400305"/>
+            <a:ext cx="10698480" cy="5029582"/>
+          </a:xfrm>
+          <a:prstGeom prst="rect">
+            <a:avLst/>
+          </a:prstGeom>
+          <a:noFill/>
+          <a:ln w="9525">
+            <a:noFill/>
+            <a:miter lim="800000"/>
+            <a:headEnd/>
+            <a:tailEnd/>
+          </a:ln>
+        </p:spPr>
+        <p:txBody>
+          <a:bodyPr wrap="square">
             <a:spAutoFit/>
           </a:bodyPr>
           <a:lstStyle/>
@@ -5013,7 +5277,7 @@
               <a:spcAft>
                 <a:spcPts val="300"/>
               </a:spcAft>
-              <a:defRPr b="1" sz="2200">
+              <a:defRPr sz="1800" b="1">
                 <a:solidFill>
                   <a:srgbClr val="003366"/>
                 </a:solidFill>
@@ -5021,9 +5285,21 @@
               </a:defRPr>
             </a:pPr>
             <a:r>
-              <a:t>Problem Statement ID: Honeywell Campus Connect — Challenge #3</a:t>
-            </a:r>
-            <a:endParaRPr lang="en-US" dirty="0"/>
+              <a:rPr sz="2100" dirty="0"/>
+              <a:t>Idea Title: ISOTHERM — Decoupled </a:t>
+            </a:r>
+            <a:r>
+              <a:rPr sz="2100" dirty="0" err="1"/>
+              <a:t>Stdio</a:t>
+            </a:r>
+            <a:r>
+              <a:rPr sz="2100" dirty="0"/>
+              <a:t> MCP Bus for Closed-Loop Physical AI Building Control</a:t>
+            </a:r>
+            <a:endParaRPr lang="en-US" sz="2100" u="sng" dirty="0">
+              <a:latin typeface="Arial" pitchFamily="34" charset="0"/>
+              <a:cs typeface="Arial" pitchFamily="34" charset="0"/>
+            </a:endParaRPr>
           </a:p>
           <a:p>
             <a:pPr>
@@ -5033,7 +5309,7 @@
               <a:spcAft>
                 <a:spcPts val="400"/>
               </a:spcAft>
-              <a:defRPr b="1" sz="2000">
+              <a:defRPr sz="1600" b="1">
                 <a:solidFill>
                   <a:srgbClr val="333333"/>
                 </a:solidFill>
@@ -5041,7 +5317,67 @@
               </a:defRPr>
             </a:pPr>
             <a:r>
-              <a:t>Problem Statement Title: ISOTHERM — Physical AI Closed-Loop Building Operations</a:t>
+              <a:rPr sz="2000" dirty="0"/>
+              <a:t>Proposed Solution Architecture:</a:t>
+            </a:r>
+          </a:p>
+          <a:p>
+            <a:pPr lvl="1">
+              <a:spcBef>
+                <a:spcPts val="200"/>
+              </a:spcBef>
+              <a:spcAft>
+                <a:spcPts val="300"/>
+              </a:spcAft>
+              <a:defRPr sz="1400" b="0">
+                <a:latin typeface="Calibri"/>
+              </a:defRPr>
+            </a:pPr>
+            <a:r>
+              <a:rPr sz="2000" dirty="0"/>
+              <a:t>• Decoupled AI Control: Couples </a:t>
+            </a:r>
+            <a:r>
+              <a:rPr sz="2000" dirty="0" err="1"/>
+              <a:t>EnergyPlus</a:t>
+            </a:r>
+            <a:r>
+              <a:rPr sz="2000" dirty="0"/>
+              <a:t> 24.1.0 physics engine with local Llama 3.1 8B via Model Context Protocol (MCP) over standard I/O pipes.</a:t>
+            </a:r>
+          </a:p>
+          <a:p>
+            <a:pPr lvl="1">
+              <a:spcBef>
+                <a:spcPts val="200"/>
+              </a:spcBef>
+              <a:spcAft>
+                <a:spcPts val="300"/>
+              </a:spcAft>
+              <a:defRPr sz="1400" b="0">
+                <a:latin typeface="Calibri"/>
+              </a:defRPr>
+            </a:pPr>
+            <a:r>
+              <a:rPr sz="2000" dirty="0"/>
+              <a:t>• 3-Hour Synchronous Callback: Blocks physics execution every 3 simulated hours, eliminating stale-setpoint drift and reducing LLM inference cycles by 87.5%.</a:t>
+            </a:r>
+          </a:p>
+          <a:p>
+            <a:pPr lvl="1">
+              <a:spcBef>
+                <a:spcPts val="200"/>
+              </a:spcBef>
+              <a:spcAft>
+                <a:spcPts val="300"/>
+              </a:spcAft>
+              <a:defRPr sz="1400" b="0">
+                <a:latin typeface="Calibri"/>
+              </a:defRPr>
+            </a:pPr>
+            <a:r>
+              <a:rPr sz="2000" dirty="0"/>
+              <a:t>• Canonical Operating Matrix: Evaluates a 7-quadrant decision table (Season × Occupancy × Utility Tariff) with real-time comfort self-correction.</a:t>
             </a:r>
           </a:p>
           <a:p>
@@ -5052,82 +5388,134 @@
               <a:spcAft>
                 <a:spcPts val="400"/>
               </a:spcAft>
-              <a:defRPr b="0" sz="1800">
+              <a:defRPr sz="1600" b="1">
                 <a:solidFill>
-                  <a:srgbClr val="505050"/>
+                  <a:srgbClr val="333333"/>
                 </a:solidFill>
                 <a:latin typeface="Calibri"/>
               </a:defRPr>
             </a:pPr>
             <a:r>
-              <a:t>Theme: Smart Buildings &amp; Sustainable AI Operations</a:t>
-            </a:r>
-          </a:p>
-          <a:p>
-            <a:pPr>
+              <a:rPr sz="2000" dirty="0"/>
+              <a:t>Innovation &amp; Uniqueness:</a:t>
+            </a:r>
+          </a:p>
+          <a:p>
+            <a:pPr lvl="1">
               <a:spcBef>
-                <a:spcPts val="800"/>
+                <a:spcPts val="200"/>
               </a:spcBef>
               <a:spcAft>
-                <a:spcPts val="400"/>
+                <a:spcPts val="300"/>
               </a:spcAft>
-              <a:defRPr b="0" sz="1800">
-                <a:solidFill>
-                  <a:srgbClr val="505050"/>
-                </a:solidFill>
+              <a:defRPr sz="1400" b="0">
                 <a:latin typeface="Calibri"/>
               </a:defRPr>
             </a:pPr>
             <a:r>
-              <a:t>PS Category: Software / AI &amp; IoT Integration</a:t>
-            </a:r>
-          </a:p>
-          <a:p>
-            <a:pPr>
+              <a:rPr sz="2000" dirty="0"/>
+              <a:t>• Joule-Exact Meter Reconciliation: Solves </a:t>
+            </a:r>
+            <a:r>
+              <a:rPr sz="2000" dirty="0" err="1"/>
+              <a:t>pyenergyplus</a:t>
+            </a:r>
+            <a:r>
+              <a:rPr sz="2000" dirty="0"/>
+              <a:t> warmup contamination to achieve 0.0000 J discrepancy against official compilation meters across 960 rows.</a:t>
+            </a:r>
+          </a:p>
+          <a:p>
+            <a:pPr lvl="1">
               <a:spcBef>
-                <a:spcPts val="800"/>
+                <a:spcPts val="200"/>
               </a:spcBef>
               <a:spcAft>
-                <a:spcPts val="400"/>
+                <a:spcPts val="300"/>
               </a:spcAft>
-              <a:defRPr b="1" sz="1800">
-                <a:solidFill>
-                  <a:srgbClr val="000000"/>
-                </a:solidFill>
+              <a:defRPr sz="1400" b="0">
                 <a:latin typeface="Calibri"/>
               </a:defRPr>
             </a:pPr>
             <a:r>
-              <a:t>Student Name: Aanid (Registered on portal)</a:t>
-            </a:r>
-          </a:p>
+              <a:rPr sz="2000" dirty="0"/>
+              <a:t>• The "Thermal Battery" Discovery: Uses morning mid-peak gas ($0.08/kWh) to warm building concrete mass, coasting during afternoon on-peak ($0.15/kWh) for a +2.9 pp comfort win while shedding load.</a:t>
+            </a:r>
+          </a:p>
+        </p:txBody>
+      </p:sp>
+      <p:sp>
+        <p:nvSpPr>
+          <p:cNvPr id="6" name="Slide Number Placeholder 5"/>
+          <p:cNvSpPr>
+            <a:spLocks noGrp="1"/>
+          </p:cNvSpPr>
+          <p:nvPr>
+            <p:ph type="sldNum" sz="quarter" idx="12"/>
+          </p:nvPr>
+        </p:nvSpPr>
+        <p:spPr/>
+        <p:txBody>
+          <a:bodyPr/>
+          <a:lstStyle/>
+          <a:p>
+            <a:fld id="{677C3CE7-23F7-4828-823C-E0205DF2CF97}" type="slidenum">
+              <a:rPr lang="en-US" b="1" smtClean="0">
+                <a:solidFill>
+                  <a:schemeClr val="bg1"/>
+                </a:solidFill>
+              </a:rPr>
+              <a:pPr/>
+              <a:t>2</a:t>
+            </a:fld>
+            <a:endParaRPr lang="en-US" b="1" dirty="0">
+              <a:solidFill>
+                <a:schemeClr val="bg1"/>
+              </a:solidFill>
+            </a:endParaRPr>
+          </a:p>
+        </p:txBody>
+      </p:sp>
+      <p:sp>
+        <p:nvSpPr>
+          <p:cNvPr id="7" name="Footer Placeholder 6"/>
+          <p:cNvSpPr>
+            <a:spLocks noGrp="1"/>
+          </p:cNvSpPr>
+          <p:nvPr>
+            <p:ph type="ftr" sz="quarter" idx="11"/>
+          </p:nvPr>
+        </p:nvSpPr>
+        <p:spPr>
+          <a:xfrm>
+            <a:off x="4648200" y="6356353"/>
+            <a:ext cx="3204000" cy="365125"/>
+          </a:xfrm>
+        </p:spPr>
+        <p:txBody>
+          <a:bodyPr/>
+          <a:lstStyle/>
           <a:p>
             <a:pPr>
-              <a:spcBef>
-                <a:spcPts val="800"/>
-              </a:spcBef>
-              <a:spcAft>
-                <a:spcPts val="400"/>
-              </a:spcAft>
-              <a:defRPr b="0" sz="1800">
+              <a:defRPr/>
+            </a:pPr>
+            <a:r>
+              <a:rPr lang="en-US">
                 <a:solidFill>
-                  <a:srgbClr val="505050"/>
+                  <a:schemeClr val="bg1"/>
                 </a:solidFill>
-                <a:latin typeface="Calibri"/>
-              </a:defRPr>
-            </a:pPr>
-            <a:r>
-              <a:t>Submission Type: Individual Submission (Honeywell Campus Connect Challenge)</a:t>
-            </a:r>
+              </a:rPr>
+              <a:t>@SIH Idea submission- Template</a:t>
+            </a:r>
+            <a:endParaRPr lang="en-US" dirty="0">
+              <a:solidFill>
+                <a:schemeClr val="bg1"/>
+              </a:solidFill>
+            </a:endParaRPr>
           </a:p>
         </p:txBody>
       </p:sp>
     </p:spTree>
-    <p:extLst>
-      <p:ext uri="{BB962C8B-B14F-4D97-AF65-F5344CB8AC3E}">
-        <p14:creationId xmlns:p14="http://schemas.microsoft.com/office/powerpoint/2010/main" val="3319884780"/>
-      </p:ext>
-    </p:extLst>
   </p:cSld>
   <p:clrMapOvr>
     <a:masterClrMapping/>
@@ -5154,7 +5542,7 @@
       </p:grpSpPr>
       <p:sp>
         <p:nvSpPr>
-          <p:cNvPr id="15361" name="Title 1"/>
+          <p:cNvPr id="17409" name="Title 1"/>
           <p:cNvSpPr>
             <a:spLocks noGrp="1"/>
           </p:cNvSpPr>
@@ -5162,38 +5550,26 @@
             <p:ph type="title"/>
           </p:nvPr>
         </p:nvSpPr>
-        <p:spPr>
-          <a:xfrm>
-            <a:off x="182998" y="0"/>
-            <a:ext cx="10972800" cy="1143000"/>
-          </a:xfrm>
-        </p:spPr>
+        <p:spPr/>
         <p:txBody>
           <a:bodyPr/>
           <a:lstStyle/>
           <a:p>
             <a:pPr eaLnBrk="1" hangingPunct="1"/>
-            <a:br>
+            <a:r>
               <a:rPr lang="en-US" sz="3600" b="1" dirty="0">
                 <a:latin typeface="Times New Roman" panose="02020603050405020304" pitchFamily="18" charset="0"/>
                 <a:ea typeface="ＭＳ Ｐゴシック" pitchFamily="1" charset="-128"/>
                 <a:cs typeface="Times New Roman" panose="02020603050405020304" pitchFamily="18" charset="0"/>
               </a:rPr>
-            </a:br>
-            <a:r>
-              <a:rPr lang="en-US" sz="3600" b="1" dirty="0">
-                <a:latin typeface="Times New Roman" panose="02020603050405020304" pitchFamily="18" charset="0"/>
-                <a:ea typeface="ＭＳ Ｐゴシック" pitchFamily="1" charset="-128"/>
-                <a:cs typeface="Times New Roman" panose="02020603050405020304" pitchFamily="18" charset="0"/>
-              </a:rPr>
-              <a:t>IDEA TITLE</a:t>
-            </a:r>
-          </a:p>
-        </p:txBody>
-      </p:sp>
-      <p:sp>
-        <p:nvSpPr>
-          <p:cNvPr id="15362" name="TextBox 8"/>
+              <a:t>TECHNICAL APPROACH</a:t>
+            </a:r>
+          </a:p>
+        </p:txBody>
+      </p:sp>
+      <p:sp>
+        <p:nvSpPr>
+          <p:cNvPr id="17410" name="TextBox 8"/>
           <p:cNvSpPr txBox="1">
             <a:spLocks noChangeArrowheads="1"/>
           </p:cNvSpPr>
@@ -5201,8 +5577,8 @@
         </p:nvSpPr>
         <p:spPr bwMode="auto">
           <a:xfrm>
-            <a:off x="731520" y="1234440"/>
-            <a:ext cx="10698480" cy="4846320"/>
+            <a:off x="792480" y="1095375"/>
+            <a:ext cx="11301984" cy="4206280"/>
           </a:xfrm>
           <a:prstGeom prst="rect">
             <a:avLst/>
@@ -5221,14 +5597,14 @@
           </a:bodyPr>
           <a:lstStyle/>
           <a:p>
-            <a:pPr>
+            <a:pPr algn="just">
               <a:spcBef>
                 <a:spcPts val="200"/>
               </a:spcBef>
               <a:spcAft>
                 <a:spcPts val="300"/>
               </a:spcAft>
-              <a:defRPr b="1" sz="1800">
+              <a:defRPr sz="1600" b="1">
                 <a:solidFill>
                   <a:srgbClr val="003366"/>
                 </a:solidFill>
@@ -5236,12 +5612,117 @@
               </a:defRPr>
             </a:pPr>
             <a:r>
-              <a:t>Idea Title: ISOTHERM — Decoupled Stdio MCP Bus for Closed-Loop Physical AI Building Control</a:t>
-            </a:r>
-            <a:endParaRPr lang="en-US" sz="3200" u="sng" dirty="0">
-              <a:latin typeface="Arial" pitchFamily="34" charset="0"/>
-              <a:cs typeface="Arial" pitchFamily="34" charset="0"/>
-            </a:endParaRPr>
+              <a:rPr sz="1600" dirty="0"/>
+              <a:t>Core Technologies &amp; Engineering Stack:</a:t>
+            </a:r>
+          </a:p>
+          <a:p>
+            <a:pPr lvl="1">
+              <a:spcBef>
+                <a:spcPts val="200"/>
+              </a:spcBef>
+              <a:spcAft>
+                <a:spcPts val="300"/>
+              </a:spcAft>
+              <a:defRPr sz="1400" b="0">
+                <a:latin typeface="Calibri"/>
+              </a:defRPr>
+            </a:pPr>
+            <a:r>
+              <a:rPr sz="1600" dirty="0"/>
+              <a:t>• Physics Engine: </a:t>
+            </a:r>
+            <a:r>
+              <a:rPr sz="1600" dirty="0" err="1"/>
+              <a:t>EnergyPlus</a:t>
+            </a:r>
+            <a:r>
+              <a:rPr sz="1600" dirty="0"/>
+              <a:t> 24.1.0 (</a:t>
+            </a:r>
+            <a:r>
+              <a:rPr sz="1600" dirty="0" err="1"/>
+              <a:t>pyenergyplus</a:t>
+            </a:r>
+            <a:r>
+              <a:rPr sz="1600" dirty="0"/>
+              <a:t> C++ runtime API with custom callback hooks).</a:t>
+            </a:r>
+          </a:p>
+          <a:p>
+            <a:pPr lvl="1">
+              <a:spcBef>
+                <a:spcPts val="200"/>
+              </a:spcBef>
+              <a:spcAft>
+                <a:spcPts val="300"/>
+              </a:spcAft>
+              <a:defRPr sz="1400" b="0">
+                <a:latin typeface="Calibri"/>
+              </a:defRPr>
+            </a:pPr>
+            <a:r>
+              <a:rPr sz="1600" dirty="0"/>
+              <a:t>• AI Orchestration: Local Llama 3.1 8B-Instruct (</a:t>
+            </a:r>
+            <a:r>
+              <a:rPr sz="1600" dirty="0" err="1"/>
+              <a:t>Ollama</a:t>
+            </a:r>
+            <a:r>
+              <a:rPr sz="1600" dirty="0"/>
+              <a:t>) executing tools over zero-latency </a:t>
+            </a:r>
+            <a:r>
+              <a:rPr sz="1600" dirty="0" err="1"/>
+              <a:t>Stdio</a:t>
+            </a:r>
+            <a:r>
+              <a:rPr sz="1600" dirty="0"/>
+              <a:t> MCP transport.</a:t>
+            </a:r>
+          </a:p>
+          <a:p>
+            <a:pPr lvl="1">
+              <a:spcBef>
+                <a:spcPts val="200"/>
+              </a:spcBef>
+              <a:spcAft>
+                <a:spcPts val="300"/>
+              </a:spcAft>
+              <a:defRPr sz="1400" b="0">
+                <a:latin typeface="Calibri"/>
+              </a:defRPr>
+            </a:pPr>
+            <a:r>
+              <a:rPr sz="1600" dirty="0"/>
+              <a:t>• State Bus: SQLite 3 (</a:t>
+            </a:r>
+            <a:r>
+              <a:rPr sz="1600" dirty="0" err="1"/>
+              <a:t>sim_state.db</a:t>
+            </a:r>
+            <a:r>
+              <a:rPr sz="1600" dirty="0"/>
+              <a:t>) capturing 15-min telemetry, atomic action queues, and decision audit logs.</a:t>
+            </a:r>
+          </a:p>
+          <a:p>
+            <a:pPr lvl="1">
+              <a:spcBef>
+                <a:spcPts val="200"/>
+              </a:spcBef>
+              <a:spcAft>
+                <a:spcPts val="300"/>
+              </a:spcAft>
+              <a:defRPr sz="1400" b="0">
+                <a:latin typeface="Calibri"/>
+              </a:defRPr>
+            </a:pPr>
+            <a:r>
+              <a:rPr sz="1600" dirty="0"/>
+              <a:t>• Presentation Dashboard: Standalone React 18 + Vite minimal luxury web app reading frozen database records with zero runtime overhead.</a:t>
+            </a:r>
           </a:p>
           <a:p>
             <a:pPr>
@@ -5251,15 +5732,16 @@
               <a:spcAft>
                 <a:spcPts val="400"/>
               </a:spcAft>
-              <a:defRPr b="1" sz="1600">
+              <a:defRPr sz="1600" b="1">
                 <a:solidFill>
-                  <a:srgbClr val="333333"/>
+                  <a:srgbClr val="003366"/>
                 </a:solidFill>
                 <a:latin typeface="Calibri"/>
               </a:defRPr>
             </a:pPr>
             <a:r>
-              <a:t>Proposed Solution Architecture:</a:t>
+              <a:rPr sz="1600" dirty="0"/>
+              <a:t>Methodology &amp; 4-Layer Defense-in-Depth Safety Hierarchy:</a:t>
             </a:r>
           </a:p>
           <a:p>
@@ -5270,12 +5752,21 @@
               <a:spcAft>
                 <a:spcPts val="300"/>
               </a:spcAft>
-              <a:defRPr b="0" sz="1400">
+              <a:defRPr sz="1400" b="0">
                 <a:latin typeface="Calibri"/>
               </a:defRPr>
             </a:pPr>
             <a:r>
-              <a:t>• Decoupled AI Control: Couples EnergyPlus 24.1.0 physics engine with local Llama 3.1 8B via Model Context Protocol (MCP) over standard I/O pipes.</a:t>
+              <a:rPr sz="1600" dirty="0"/>
+              <a:t>• Layer 1 (Schema Validation): </a:t>
+            </a:r>
+            <a:r>
+              <a:rPr sz="1600" dirty="0" err="1"/>
+              <a:t>Pydantic</a:t>
+            </a:r>
+            <a:r>
+              <a:rPr sz="1600" dirty="0"/>
+              <a:t> JSON parser intercepts syntax errors and malformed tool calls before execution.</a:t>
             </a:r>
           </a:p>
           <a:p>
@@ -5286,12 +5777,13 @@
               <a:spcAft>
                 <a:spcPts val="300"/>
               </a:spcAft>
-              <a:defRPr b="0" sz="1400">
+              <a:defRPr sz="1400" b="0">
                 <a:latin typeface="Calibri"/>
               </a:defRPr>
             </a:pPr>
             <a:r>
-              <a:t>• 3-Hour Synchronous Callback: Blocks physics execution every 3 simulated hours, eliminating stale-setpoint drift and reducing LLM inference cycles by 87.5%.</a:t>
+              <a:rPr sz="1600" dirty="0"/>
+              <a:t>• Layer 2 (Timeout Fallback): 60-second sub-process timer injects canonical setback defaults (16°C/27°C) if GPU inference throttles.</a:t>
             </a:r>
           </a:p>
           <a:p>
@@ -5302,31 +5794,13 @@
               <a:spcAft>
                 <a:spcPts val="300"/>
               </a:spcAft>
-              <a:defRPr b="0" sz="1400">
+              <a:defRPr sz="1400" b="0">
                 <a:latin typeface="Calibri"/>
               </a:defRPr>
             </a:pPr>
             <a:r>
-              <a:t>• Canonical Operating Matrix: Evaluates a 7-quadrant decision table (Season × Occupancy × Utility Tariff) with real-time comfort self-correction.</a:t>
-            </a:r>
-          </a:p>
-          <a:p>
-            <a:pPr>
-              <a:spcBef>
-                <a:spcPts val="800"/>
-              </a:spcBef>
-              <a:spcAft>
-                <a:spcPts val="400"/>
-              </a:spcAft>
-              <a:defRPr b="1" sz="1600">
-                <a:solidFill>
-                  <a:srgbClr val="333333"/>
-                </a:solidFill>
-                <a:latin typeface="Calibri"/>
-              </a:defRPr>
-            </a:pPr>
-            <a:r>
-              <a:t>Innovation &amp; Uniqueness:</a:t>
+              <a:rPr sz="1600" dirty="0"/>
+              <a:t>• Layer 3 (Hard Code Clamps): Deterministic Python bounds enforce 16–24°C heating, 22–30°C cooling, and &gt;= 2°C deadband before API writes.</a:t>
             </a:r>
           </a:p>
           <a:p>
@@ -5337,28 +5811,13 @@
               <a:spcAft>
                 <a:spcPts val="300"/>
               </a:spcAft>
-              <a:defRPr b="0" sz="1400">
+              <a:defRPr sz="1400" b="0">
                 <a:latin typeface="Calibri"/>
               </a:defRPr>
             </a:pPr>
             <a:r>
-              <a:t>• Joule-Exact Meter Reconciliation: Solves pyenergyplus warmup contamination to achieve 0.0000 J discrepancy against official compilation meters across 960 rows.</a:t>
-            </a:r>
-          </a:p>
-          <a:p>
-            <a:pPr lvl="1">
-              <a:spcBef>
-                <a:spcPts val="200"/>
-              </a:spcBef>
-              <a:spcAft>
-                <a:spcPts val="300"/>
-              </a:spcAft>
-              <a:defRPr b="0" sz="1400">
-                <a:latin typeface="Calibri"/>
-              </a:defRPr>
-            </a:pPr>
-            <a:r>
-              <a:t>• The "Thermal Battery" Discovery: Uses morning mid-peak gas ($0.08/kWh) to warm building concrete mass, coasting during afternoon on-peak ($0.15/kWh) for a +2.9 pp comfort win while shedding load.</a:t>
+              <a:rPr sz="1600" dirty="0"/>
+              <a:t>• Layer 4 (Spatial Independence): 10 independent schedule compact handles eliminate global schedule conflicts across all 5 zones.</a:t>
             </a:r>
           </a:p>
         </p:txBody>
@@ -5379,7 +5838,7 @@
           <a:lstStyle/>
           <a:p>
             <a:fld id="{677C3CE7-23F7-4828-823C-E0205DF2CF97}" type="slidenum">
-              <a:rPr lang="en-US" b="1" smtClean="0">
+              <a:rPr lang="en-US" b="1">
                 <a:solidFill>
                   <a:schemeClr val="bg1"/>
                 </a:solidFill>
@@ -5419,18 +5878,13 @@
               <a:defRPr/>
             </a:pPr>
             <a:r>
-              <a:rPr lang="en-US">
+              <a:rPr lang="en-US" dirty="0">
                 <a:solidFill>
                   <a:schemeClr val="bg1"/>
                 </a:solidFill>
               </a:rPr>
               <a:t>@SIH Idea submission- Template</a:t>
             </a:r>
-            <a:endParaRPr lang="en-US" dirty="0">
-              <a:solidFill>
-                <a:schemeClr val="bg1"/>
-              </a:solidFill>
-            </a:endParaRPr>
           </a:p>
         </p:txBody>
       </p:sp>
@@ -5481,7 +5935,7 @@
                 <a:ea typeface="ＭＳ Ｐゴシック" pitchFamily="1" charset="-128"/>
                 <a:cs typeface="Times New Roman" panose="02020603050405020304" pitchFamily="18" charset="0"/>
               </a:rPr>
-              <a:t>TECHNICAL APPROACH</a:t>
+              <a:t>FEASIBILITY AND VIABILITY</a:t>
             </a:r>
           </a:p>
         </p:txBody>
@@ -5496,8 +5950,8 @@
         </p:nvSpPr>
         <p:spPr bwMode="auto">
           <a:xfrm>
-            <a:off x="731520" y="1234440"/>
-            <a:ext cx="10698480" cy="4846320"/>
+            <a:off x="746760" y="1095375"/>
+            <a:ext cx="10698480" cy="5191165"/>
           </a:xfrm>
           <a:prstGeom prst="rect">
             <a:avLst/>
@@ -5516,329 +5970,7 @@
           </a:bodyPr>
           <a:lstStyle/>
           <a:p>
-            <a:pPr marL="342900" indent="-342900" algn="just">
-              <a:spcBef>
-                <a:spcPts val="200"/>
-              </a:spcBef>
-              <a:spcAft>
-                <a:spcPts val="300"/>
-              </a:spcAft>
-              <a:buFont typeface="Arial" panose="020B0604020202020204" pitchFamily="34" charset="0"/>
-              <a:buChar char="•"/>
-              <a:defRPr b="1" sz="1600">
-                <a:solidFill>
-                  <a:srgbClr val="003366"/>
-                </a:solidFill>
-                <a:latin typeface="Calibri"/>
-              </a:defRPr>
-            </a:pPr>
-            <a:r>
-              <a:t>Core Technologies &amp; Engineering Stack:</a:t>
-            </a:r>
-          </a:p>
-          <a:p>
-            <a:pPr lvl="1">
-              <a:spcBef>
-                <a:spcPts val="200"/>
-              </a:spcBef>
-              <a:spcAft>
-                <a:spcPts val="300"/>
-              </a:spcAft>
-              <a:defRPr b="0" sz="1400">
-                <a:latin typeface="Calibri"/>
-              </a:defRPr>
-            </a:pPr>
-            <a:r>
-              <a:t>• Physics Engine: EnergyPlus 24.1.0 (pyenergyplus C++ runtime API with custom callback hooks).</a:t>
-            </a:r>
-          </a:p>
-          <a:p>
-            <a:pPr lvl="1">
-              <a:spcBef>
-                <a:spcPts val="200"/>
-              </a:spcBef>
-              <a:spcAft>
-                <a:spcPts val="300"/>
-              </a:spcAft>
-              <a:defRPr b="0" sz="1400">
-                <a:latin typeface="Calibri"/>
-              </a:defRPr>
-            </a:pPr>
-            <a:r>
-              <a:t>• AI Orchestration: Local Llama 3.1 8B-Instruct (Ollama) executing tools over zero-latency Stdio MCP transport.</a:t>
-            </a:r>
-          </a:p>
-          <a:p>
-            <a:pPr lvl="1">
-              <a:spcBef>
-                <a:spcPts val="200"/>
-              </a:spcBef>
-              <a:spcAft>
-                <a:spcPts val="300"/>
-              </a:spcAft>
-              <a:defRPr b="0" sz="1400">
-                <a:latin typeface="Calibri"/>
-              </a:defRPr>
-            </a:pPr>
-            <a:r>
-              <a:t>• State Bus: SQLite 3 (sim_state.db) capturing 15-min telemetry, atomic action queues, and decision audit logs.</a:t>
-            </a:r>
-          </a:p>
-          <a:p>
-            <a:pPr lvl="1">
-              <a:spcBef>
-                <a:spcPts val="200"/>
-              </a:spcBef>
-              <a:spcAft>
-                <a:spcPts val="300"/>
-              </a:spcAft>
-              <a:defRPr b="0" sz="1400">
-                <a:latin typeface="Calibri"/>
-              </a:defRPr>
-            </a:pPr>
-            <a:r>
-              <a:t>• Presentation Dashboard: Standalone React 18 + Vite minimal luxury web app reading frozen database records with zero runtime overhead.</a:t>
-            </a:r>
-          </a:p>
-          <a:p>
-            <a:pPr>
-              <a:spcBef>
-                <a:spcPts val="800"/>
-              </a:spcBef>
-              <a:spcAft>
-                <a:spcPts val="400"/>
-              </a:spcAft>
-              <a:defRPr b="1" sz="1600">
-                <a:solidFill>
-                  <a:srgbClr val="003366"/>
-                </a:solidFill>
-                <a:latin typeface="Calibri"/>
-              </a:defRPr>
-            </a:pPr>
-            <a:r>
-              <a:t>Methodology &amp; 4-Layer Defense-in-Depth Safety Hierarchy:</a:t>
-            </a:r>
-          </a:p>
-          <a:p>
-            <a:pPr lvl="1">
-              <a:spcBef>
-                <a:spcPts val="200"/>
-              </a:spcBef>
-              <a:spcAft>
-                <a:spcPts val="300"/>
-              </a:spcAft>
-              <a:defRPr b="0" sz="1400">
-                <a:latin typeface="Calibri"/>
-              </a:defRPr>
-            </a:pPr>
-            <a:r>
-              <a:t>• Layer 1 (Schema Validation): Pydantic JSON parser intercepts syntax errors and malformed tool calls before execution.</a:t>
-            </a:r>
-          </a:p>
-          <a:p>
-            <a:pPr lvl="1">
-              <a:spcBef>
-                <a:spcPts val="200"/>
-              </a:spcBef>
-              <a:spcAft>
-                <a:spcPts val="300"/>
-              </a:spcAft>
-              <a:defRPr b="0" sz="1400">
-                <a:latin typeface="Calibri"/>
-              </a:defRPr>
-            </a:pPr>
-            <a:r>
-              <a:t>• Layer 2 (Timeout Fallback): 60-second sub-process timer injects canonical setback defaults (16°C/27°C) if GPU inference throttles.</a:t>
-            </a:r>
-          </a:p>
-          <a:p>
-            <a:pPr lvl="1">
-              <a:spcBef>
-                <a:spcPts val="200"/>
-              </a:spcBef>
-              <a:spcAft>
-                <a:spcPts val="300"/>
-              </a:spcAft>
-              <a:defRPr b="0" sz="1400">
-                <a:latin typeface="Calibri"/>
-              </a:defRPr>
-            </a:pPr>
-            <a:r>
-              <a:t>• Layer 3 (Hard Code Clamps): Deterministic Python bounds enforce 16–24°C heating, 22–30°C cooling, and &gt;= 2°C deadband before API writes.</a:t>
-            </a:r>
-          </a:p>
-          <a:p>
-            <a:pPr lvl="1">
-              <a:spcBef>
-                <a:spcPts val="200"/>
-              </a:spcBef>
-              <a:spcAft>
-                <a:spcPts val="300"/>
-              </a:spcAft>
-              <a:defRPr b="0" sz="1400">
-                <a:latin typeface="Calibri"/>
-              </a:defRPr>
-            </a:pPr>
-            <a:r>
-              <a:t>• Layer 4 (Spatial Independence): 10 independent schedule compact handles eliminate global schedule conflicts across all 5 zones.</a:t>
-            </a:r>
-          </a:p>
-        </p:txBody>
-      </p:sp>
-      <p:sp>
-        <p:nvSpPr>
-          <p:cNvPr id="6" name="Slide Number Placeholder 5"/>
-          <p:cNvSpPr>
-            <a:spLocks noGrp="1"/>
-          </p:cNvSpPr>
-          <p:nvPr>
-            <p:ph type="sldNum" sz="quarter" idx="12"/>
-          </p:nvPr>
-        </p:nvSpPr>
-        <p:spPr/>
-        <p:txBody>
-          <a:bodyPr/>
-          <a:lstStyle/>
-          <a:p>
-            <a:fld id="{677C3CE7-23F7-4828-823C-E0205DF2CF97}" type="slidenum">
-              <a:rPr lang="en-US" b="1">
-                <a:solidFill>
-                  <a:schemeClr val="bg1"/>
-                </a:solidFill>
-              </a:rPr>
-              <a:pPr/>
-              <a:t>4</a:t>
-            </a:fld>
-            <a:endParaRPr lang="en-US" b="1" dirty="0">
-              <a:solidFill>
-                <a:schemeClr val="bg1"/>
-              </a:solidFill>
-            </a:endParaRPr>
-          </a:p>
-        </p:txBody>
-      </p:sp>
-      <p:sp>
-        <p:nvSpPr>
-          <p:cNvPr id="7" name="Footer Placeholder 6"/>
-          <p:cNvSpPr>
-            <a:spLocks noGrp="1"/>
-          </p:cNvSpPr>
-          <p:nvPr>
-            <p:ph type="ftr" sz="quarter" idx="11"/>
-          </p:nvPr>
-        </p:nvSpPr>
-        <p:spPr>
-          <a:xfrm>
-            <a:off x="4648200" y="6356353"/>
-            <a:ext cx="3204000" cy="365125"/>
-          </a:xfrm>
-        </p:spPr>
-        <p:txBody>
-          <a:bodyPr/>
-          <a:lstStyle/>
-          <a:p>
-            <a:pPr>
-              <a:defRPr/>
-            </a:pPr>
-            <a:r>
-              <a:rPr lang="en-US">
-                <a:solidFill>
-                  <a:schemeClr val="bg1"/>
-                </a:solidFill>
-              </a:rPr>
-              <a:t>@SIH Idea submission- Template</a:t>
-            </a:r>
-            <a:endParaRPr lang="en-US" dirty="0">
-              <a:solidFill>
-                <a:schemeClr val="bg1"/>
-              </a:solidFill>
-            </a:endParaRPr>
-          </a:p>
-        </p:txBody>
-      </p:sp>
-    </p:spTree>
-  </p:cSld>
-  <p:clrMapOvr>
-    <a:masterClrMapping/>
-  </p:clrMapOvr>
-</p:sld>
-</file>
-
-<file path=ppt/slides/slide5.xml><?xml version="1.0" encoding="utf-8"?>
-<p:sld xmlns:a="http://schemas.openxmlformats.org/drawingml/2006/main" xmlns:r="http://schemas.openxmlformats.org/officeDocument/2006/relationships" xmlns:p="http://schemas.openxmlformats.org/presentationml/2006/main">
-  <p:cSld>
-    <p:spTree>
-      <p:nvGrpSpPr>
-        <p:cNvPr id="1" name=""/>
-        <p:cNvGrpSpPr/>
-        <p:nvPr/>
-      </p:nvGrpSpPr>
-      <p:grpSpPr>
-        <a:xfrm>
-          <a:off x="0" y="0"/>
-          <a:ext cx="0" cy="0"/>
-          <a:chOff x="0" y="0"/>
-          <a:chExt cx="0" cy="0"/>
-        </a:xfrm>
-      </p:grpSpPr>
-      <p:sp>
-        <p:nvSpPr>
-          <p:cNvPr id="17409" name="Title 1"/>
-          <p:cNvSpPr>
-            <a:spLocks noGrp="1"/>
-          </p:cNvSpPr>
-          <p:nvPr>
-            <p:ph type="title"/>
-          </p:nvPr>
-        </p:nvSpPr>
-        <p:spPr/>
-        <p:txBody>
-          <a:bodyPr/>
-          <a:lstStyle/>
-          <a:p>
-            <a:pPr eaLnBrk="1" hangingPunct="1"/>
-            <a:r>
-              <a:rPr lang="en-US" sz="3600" b="1" dirty="0">
-                <a:latin typeface="Times New Roman" panose="02020603050405020304" pitchFamily="18" charset="0"/>
-                <a:ea typeface="ＭＳ Ｐゴシック" pitchFamily="1" charset="-128"/>
-                <a:cs typeface="Times New Roman" panose="02020603050405020304" pitchFamily="18" charset="0"/>
-              </a:rPr>
-              <a:t>FEASIBILITY AND VIABILITY</a:t>
-            </a:r>
-          </a:p>
-        </p:txBody>
-      </p:sp>
-      <p:sp>
-        <p:nvSpPr>
-          <p:cNvPr id="17410" name="TextBox 8"/>
-          <p:cNvSpPr txBox="1">
-            <a:spLocks noChangeArrowheads="1"/>
-          </p:cNvSpPr>
-          <p:nvPr/>
-        </p:nvSpPr>
-        <p:spPr bwMode="auto">
-          <a:xfrm>
-            <a:off x="731520" y="1234440"/>
-            <a:ext cx="10698480" cy="4846320"/>
-          </a:xfrm>
-          <a:prstGeom prst="rect">
-            <a:avLst/>
-          </a:prstGeom>
-          <a:noFill/>
-          <a:ln w="9525">
-            <a:noFill/>
-            <a:miter lim="800000"/>
-            <a:headEnd/>
-            <a:tailEnd/>
-          </a:ln>
-        </p:spPr>
-        <p:txBody>
-          <a:bodyPr wrap="square">
-            <a:spAutoFit/>
-          </a:bodyPr>
-          <a:lstStyle/>
-          <a:p>
-            <a:pPr marL="342900" marR="0" indent="-342900" algn="just" defTabSz="457200" rtl="0" eaLnBrk="1" fontAlgn="base" latinLnBrk="0" hangingPunct="1">
+            <a:pPr marR="0" algn="just" defTabSz="457200" rtl="0" eaLnBrk="1" fontAlgn="base" latinLnBrk="0" hangingPunct="1">
               <a:lnSpc>
                 <a:spcPct val="100000"/>
               </a:lnSpc>
@@ -5850,10 +5982,8 @@
               </a:spcAft>
               <a:buClrTx/>
               <a:buSzTx/>
-              <a:buFont typeface="Arial" panose="020B0604020202020204" pitchFamily="34" charset="0"/>
-              <a:buChar char="•"/>
               <a:tabLst/>
-              <a:defRPr b="1" sz="1600">
+              <a:defRPr sz="1600" b="1">
                 <a:solidFill>
                   <a:srgbClr val="003366"/>
                 </a:solidFill>
@@ -5861,9 +5991,10 @@
               </a:defRPr>
             </a:pPr>
             <a:r>
+              <a:rPr sz="1600" dirty="0"/>
               <a:t>Feasibility &amp; Computational Efficiency:</a:t>
             </a:r>
-            <a:endParaRPr kumimoji="0" lang="en-US" sz="2800" b="0" i="0" u="none" strike="noStrike" kern="1200" cap="none" spc="0" normalizeH="0" baseline="0" noProof="0" dirty="0">
+            <a:endParaRPr kumimoji="0" lang="en-US" sz="1600" b="0" i="0" u="none" strike="noStrike" kern="1200" cap="none" spc="0" normalizeH="0" baseline="0" noProof="0" dirty="0">
               <a:ln>
                 <a:noFill/>
               </a:ln>
@@ -5886,11 +6017,12 @@
               <a:spcAft>
                 <a:spcPts val="300"/>
               </a:spcAft>
-              <a:defRPr b="0" sz="1400">
+              <a:defRPr sz="1400" b="0">
                 <a:latin typeface="Calibri"/>
               </a:defRPr>
             </a:pPr>
             <a:r>
+              <a:rPr sz="1600" dirty="0"/>
               <a:t>• 100% Local Enterprise Execution: Operates on standard hybrid CPU/GPU hardware without cloud API dependencies or recurring token costs.</a:t>
             </a:r>
           </a:p>
@@ -5902,11 +6034,12 @@
               <a:spcAft>
                 <a:spcPts val="300"/>
               </a:spcAft>
-              <a:defRPr b="0" sz="1400">
+              <a:defRPr sz="1400" b="0">
                 <a:latin typeface="Calibri"/>
               </a:defRPr>
             </a:pPr>
             <a:r>
+              <a:rPr sz="1600" dirty="0"/>
               <a:t>• Low Runtime Overhead: 3-hour control cadence completes multi-day building simulations in under 2 minutes of wall-clock time.</a:t>
             </a:r>
           </a:p>
@@ -5918,7 +6051,7 @@
               <a:spcAft>
                 <a:spcPts val="400"/>
               </a:spcAft>
-              <a:defRPr b="1" sz="1600">
+              <a:defRPr sz="1600" b="1">
                 <a:solidFill>
                   <a:srgbClr val="003366"/>
                 </a:solidFill>
@@ -5926,6 +6059,7 @@
               </a:defRPr>
             </a:pPr>
             <a:r>
+              <a:rPr sz="1600" dirty="0"/>
               <a:t>Potential Challenges &amp; Engineered Mitigations:</a:t>
             </a:r>
           </a:p>
@@ -5937,11 +6071,12 @@
               <a:spcAft>
                 <a:spcPts val="300"/>
               </a:spcAft>
-              <a:defRPr b="0" sz="1400">
+              <a:defRPr sz="1400" b="0">
                 <a:latin typeface="Calibri"/>
               </a:defRPr>
             </a:pPr>
             <a:r>
+              <a:rPr sz="1600" dirty="0"/>
               <a:t>• Challenge: LLM Hallucinations — Free-form prompts risk out-of-bounds setpoints or rapid valve cycling that crashes C++ solver convergence.</a:t>
             </a:r>
           </a:p>
@@ -5953,7 +6088,7 @@
               <a:spcAft>
                 <a:spcPts val="300"/>
               </a:spcAft>
-              <a:defRPr b="0" sz="1300">
+              <a:defRPr sz="1300" b="0">
                 <a:solidFill>
                   <a:srgbClr val="464646"/>
                 </a:solidFill>
@@ -5961,6 +6096,7 @@
               </a:defRPr>
             </a:pPr>
             <a:r>
+              <a:rPr sz="1600" dirty="0"/>
               <a:t>  -&gt; Mitigation: Restricted LLM role to canonical decision-table evaluation with comfort-feedback self-correction overrides.</a:t>
             </a:r>
           </a:p>
@@ -5972,12 +6108,21 @@
               <a:spcAft>
                 <a:spcPts val="300"/>
               </a:spcAft>
-              <a:defRPr b="0" sz="1400">
+              <a:defRPr sz="1400" b="0">
                 <a:latin typeface="Calibri"/>
               </a:defRPr>
             </a:pPr>
             <a:r>
-              <a:t>• Challenge: Telemetry Contamination — Silent EnergyPlus warmup days pollute database logging and distort baseline savings.</a:t>
+              <a:rPr sz="1600" dirty="0"/>
+              <a:t>• Challenge: Telemetry Contamination — Silent </a:t>
+            </a:r>
+            <a:r>
+              <a:rPr sz="1600" dirty="0" err="1"/>
+              <a:t>EnergyPlus</a:t>
+            </a:r>
+            <a:r>
+              <a:rPr sz="1600" dirty="0"/>
+              <a:t> warmup days pollute database logging and distort baseline savings.</a:t>
             </a:r>
           </a:p>
           <a:p>
@@ -5988,7 +6133,7 @@
               <a:spcAft>
                 <a:spcPts val="300"/>
               </a:spcAft>
-              <a:defRPr b="0" sz="1300">
+              <a:defRPr sz="1300" b="0">
                 <a:solidFill>
                   <a:srgbClr val="464646"/>
                 </a:solidFill>
@@ -5996,7 +6141,24 @@
               </a:defRPr>
             </a:pPr>
             <a:r>
-              <a:t>  -&gt; Mitigation: Implemented explicit pyenergyplus warmup interlock (warmup_flag guard), achieving Joule-exact meter reconciliation.</a:t>
+              <a:rPr sz="1600" dirty="0"/>
+              <a:t>  -&gt; Mitigation: Implemented explicit </a:t>
+            </a:r>
+            <a:r>
+              <a:rPr sz="1600" dirty="0" err="1"/>
+              <a:t>pyenergyplus</a:t>
+            </a:r>
+            <a:r>
+              <a:rPr sz="1600" dirty="0"/>
+              <a:t> warmup interlock (</a:t>
+            </a:r>
+            <a:r>
+              <a:rPr sz="1600" dirty="0" err="1"/>
+              <a:t>warmup_flag</a:t>
+            </a:r>
+            <a:r>
+              <a:rPr sz="1600" dirty="0"/>
+              <a:t> guard), achieving Joule-exact meter reconciliation.</a:t>
             </a:r>
           </a:p>
           <a:p>
@@ -6007,11 +6169,12 @@
               <a:spcAft>
                 <a:spcPts val="300"/>
               </a:spcAft>
-              <a:defRPr b="0" sz="1400">
+              <a:defRPr sz="1400" b="0">
                 <a:latin typeface="Calibri"/>
               </a:defRPr>
             </a:pPr>
             <a:r>
+              <a:rPr sz="1600" dirty="0"/>
               <a:t>• Challenge: VAV Reheat Waste — Perimeter cooling over-cools interior core zones, forcing hot-water reheat coils to fight central chillers.</a:t>
             </a:r>
           </a:p>
@@ -6023,7 +6186,7 @@
               <a:spcAft>
                 <a:spcPts val="300"/>
               </a:spcAft>
-              <a:defRPr b="0" sz="1300">
+              <a:defRPr sz="1300" b="0">
                 <a:solidFill>
                   <a:srgbClr val="464646"/>
                 </a:solidFill>
@@ -6031,6 +6194,7 @@
               </a:defRPr>
             </a:pPr>
             <a:r>
+              <a:rPr sz="1600" dirty="0"/>
               <a:t>  -&gt; Mitigation: Enforced season-aware prompt clamping (16.0°C summer floor), achieving 100% elimination of summer reheat waste (0.00 kW peak reheat).</a:t>
             </a:r>
           </a:p>
@@ -6039,6 +6203,477 @@
       <p:sp>
         <p:nvSpPr>
           <p:cNvPr id="6" name="Slide Number Placeholder 5"/>
+          <p:cNvSpPr>
+            <a:spLocks noGrp="1"/>
+          </p:cNvSpPr>
+          <p:nvPr>
+            <p:ph type="sldNum" sz="quarter" idx="12"/>
+          </p:nvPr>
+        </p:nvSpPr>
+        <p:spPr/>
+        <p:txBody>
+          <a:bodyPr/>
+          <a:lstStyle/>
+          <a:p>
+            <a:pPr marL="0" marR="0" lvl="0" indent="0" algn="r" defTabSz="457200" rtl="0" eaLnBrk="1" fontAlgn="base" latinLnBrk="0" hangingPunct="1">
+              <a:lnSpc>
+                <a:spcPct val="100000"/>
+              </a:lnSpc>
+              <a:spcBef>
+                <a:spcPct val="0"/>
+              </a:spcBef>
+              <a:spcAft>
+                <a:spcPct val="0"/>
+              </a:spcAft>
+              <a:buClrTx/>
+              <a:buSzTx/>
+              <a:buFontTx/>
+              <a:buNone/>
+              <a:tabLst/>
+              <a:defRPr/>
+            </a:pPr>
+            <a:fld id="{677C3CE7-23F7-4828-823C-E0205DF2CF97}" type="slidenum">
+              <a:rPr kumimoji="0" lang="en-US" sz="1200" b="1" i="0" u="none" strike="noStrike" kern="1200" cap="none" spc="0" normalizeH="0" baseline="0" noProof="0">
+                <a:ln>
+                  <a:noFill/>
+                </a:ln>
+                <a:solidFill>
+                  <a:prstClr val="white"/>
+                </a:solidFill>
+                <a:effectLst/>
+                <a:uLnTx/>
+                <a:uFillTx/>
+                <a:latin typeface="TradeGothic" pitchFamily="1" charset="0"/>
+                <a:ea typeface="ＭＳ Ｐゴシック" pitchFamily="1" charset="-128"/>
+                <a:cs typeface="+mn-cs"/>
+              </a:rPr>
+              <a:pPr marL="0" marR="0" lvl="0" indent="0" algn="r" defTabSz="457200" rtl="0" eaLnBrk="1" fontAlgn="base" latinLnBrk="0" hangingPunct="1">
+                <a:lnSpc>
+                  <a:spcPct val="100000"/>
+                </a:lnSpc>
+                <a:spcBef>
+                  <a:spcPct val="0"/>
+                </a:spcBef>
+                <a:spcAft>
+                  <a:spcPct val="0"/>
+                </a:spcAft>
+                <a:buClrTx/>
+                <a:buSzTx/>
+                <a:buFontTx/>
+                <a:buNone/>
+                <a:tabLst/>
+                <a:defRPr/>
+              </a:pPr>
+              <a:t>4</a:t>
+            </a:fld>
+            <a:endParaRPr kumimoji="0" lang="en-US" sz="1200" b="1" i="0" u="none" strike="noStrike" kern="1200" cap="none" spc="0" normalizeH="0" baseline="0" noProof="0" dirty="0">
+              <a:ln>
+                <a:noFill/>
+              </a:ln>
+              <a:solidFill>
+                <a:prstClr val="white"/>
+              </a:solidFill>
+              <a:effectLst/>
+              <a:uLnTx/>
+              <a:uFillTx/>
+              <a:latin typeface="TradeGothic" pitchFamily="1" charset="0"/>
+              <a:ea typeface="ＭＳ Ｐゴシック" pitchFamily="1" charset="-128"/>
+              <a:cs typeface="+mn-cs"/>
+            </a:endParaRPr>
+          </a:p>
+        </p:txBody>
+      </p:sp>
+      <p:sp>
+        <p:nvSpPr>
+          <p:cNvPr id="7" name="Footer Placeholder 6"/>
+          <p:cNvSpPr>
+            <a:spLocks noGrp="1"/>
+          </p:cNvSpPr>
+          <p:nvPr>
+            <p:ph type="ftr" sz="quarter" idx="11"/>
+          </p:nvPr>
+        </p:nvSpPr>
+        <p:spPr>
+          <a:xfrm>
+            <a:off x="4648200" y="6356353"/>
+            <a:ext cx="3204000" cy="365125"/>
+          </a:xfrm>
+        </p:spPr>
+        <p:txBody>
+          <a:bodyPr/>
+          <a:lstStyle/>
+          <a:p>
+            <a:pPr marL="0" marR="0" lvl="0" indent="0" algn="ctr" defTabSz="457200" rtl="0" eaLnBrk="1" fontAlgn="auto" latinLnBrk="0" hangingPunct="1">
+              <a:lnSpc>
+                <a:spcPct val="100000"/>
+              </a:lnSpc>
+              <a:spcBef>
+                <a:spcPts val="0"/>
+              </a:spcBef>
+              <a:spcAft>
+                <a:spcPts val="0"/>
+              </a:spcAft>
+              <a:buClrTx/>
+              <a:buSzTx/>
+              <a:buFontTx/>
+              <a:buNone/>
+              <a:tabLst/>
+              <a:defRPr/>
+            </a:pPr>
+            <a:r>
+              <a:rPr kumimoji="0" lang="en-US" sz="1200" b="0" i="0" u="none" strike="noStrike" kern="1200" cap="none" spc="0" normalizeH="0" baseline="0" noProof="0">
+                <a:ln>
+                  <a:noFill/>
+                </a:ln>
+                <a:solidFill>
+                  <a:prstClr val="white"/>
+                </a:solidFill>
+                <a:effectLst/>
+                <a:uLnTx/>
+                <a:uFillTx/>
+                <a:latin typeface="TradeGothic"/>
+                <a:ea typeface="+mn-ea"/>
+                <a:cs typeface="+mn-cs"/>
+              </a:rPr>
+              <a:t>@SIH Idea submission- Template</a:t>
+            </a:r>
+            <a:endParaRPr kumimoji="0" lang="en-US" sz="1200" b="0" i="0" u="none" strike="noStrike" kern="1200" cap="none" spc="0" normalizeH="0" baseline="0" noProof="0" dirty="0">
+              <a:ln>
+                <a:noFill/>
+              </a:ln>
+              <a:solidFill>
+                <a:prstClr val="white"/>
+              </a:solidFill>
+              <a:effectLst/>
+              <a:uLnTx/>
+              <a:uFillTx/>
+              <a:latin typeface="TradeGothic"/>
+              <a:ea typeface="+mn-ea"/>
+              <a:cs typeface="+mn-cs"/>
+            </a:endParaRPr>
+          </a:p>
+        </p:txBody>
+      </p:sp>
+    </p:spTree>
+    <p:extLst>
+      <p:ext uri="{BB962C8B-B14F-4D97-AF65-F5344CB8AC3E}">
+        <p14:creationId xmlns:p14="http://schemas.microsoft.com/office/powerpoint/2010/main" val="3753387913"/>
+      </p:ext>
+    </p:extLst>
+  </p:cSld>
+  <p:clrMapOvr>
+    <a:masterClrMapping/>
+  </p:clrMapOvr>
+</p:sld>
+</file>
+
+<file path=ppt/slides/slide5.xml><?xml version="1.0" encoding="utf-8"?>
+<p:sld xmlns:a="http://schemas.openxmlformats.org/drawingml/2006/main" xmlns:r="http://schemas.openxmlformats.org/officeDocument/2006/relationships" xmlns:p="http://schemas.openxmlformats.org/presentationml/2006/main">
+  <p:cSld>
+    <p:spTree>
+      <p:nvGrpSpPr>
+        <p:cNvPr id="1" name="">
+          <a:extLst>
+            <a:ext uri="{FF2B5EF4-FFF2-40B4-BE49-F238E27FC236}">
+              <a16:creationId xmlns:a16="http://schemas.microsoft.com/office/drawing/2014/main" id="{48B09052-50AE-B3C2-6A1C-5CFF37D94A7E}"/>
+            </a:ext>
+          </a:extLst>
+        </p:cNvPr>
+        <p:cNvGrpSpPr/>
+        <p:nvPr/>
+      </p:nvGrpSpPr>
+      <p:grpSpPr>
+        <a:xfrm>
+          <a:off x="0" y="0"/>
+          <a:ext cx="0" cy="0"/>
+          <a:chOff x="0" y="0"/>
+          <a:chExt cx="0" cy="0"/>
+        </a:xfrm>
+      </p:grpSpPr>
+      <p:sp>
+        <p:nvSpPr>
+          <p:cNvPr id="17409" name="Title 1">
+            <a:extLst>
+              <a:ext uri="{FF2B5EF4-FFF2-40B4-BE49-F238E27FC236}">
+                <a16:creationId xmlns:a16="http://schemas.microsoft.com/office/drawing/2014/main" id="{5E03BF1A-7989-5C44-934B-D93E149184A6}"/>
+              </a:ext>
+            </a:extLst>
+          </p:cNvPr>
+          <p:cNvSpPr>
+            <a:spLocks noGrp="1"/>
+          </p:cNvSpPr>
+          <p:nvPr>
+            <p:ph type="title"/>
+          </p:nvPr>
+        </p:nvSpPr>
+        <p:spPr/>
+        <p:txBody>
+          <a:bodyPr/>
+          <a:lstStyle/>
+          <a:p>
+            <a:pPr eaLnBrk="1" hangingPunct="1"/>
+            <a:r>
+              <a:rPr lang="en-US" sz="3600" b="1" dirty="0">
+                <a:latin typeface="Times New Roman" panose="02020603050405020304" pitchFamily="18" charset="0"/>
+                <a:ea typeface="ＭＳ Ｐゴシック" pitchFamily="1" charset="-128"/>
+                <a:cs typeface="Times New Roman" panose="02020603050405020304" pitchFamily="18" charset="0"/>
+              </a:rPr>
+              <a:t>ARTIFACTS</a:t>
+            </a:r>
+          </a:p>
+        </p:txBody>
+      </p:sp>
+      <p:sp>
+        <p:nvSpPr>
+          <p:cNvPr id="17410" name="TextBox 8">
+            <a:extLst>
+              <a:ext uri="{FF2B5EF4-FFF2-40B4-BE49-F238E27FC236}">
+                <a16:creationId xmlns:a16="http://schemas.microsoft.com/office/drawing/2014/main" id="{DD0C6F84-D6ED-416D-7179-055149D83FA6}"/>
+              </a:ext>
+            </a:extLst>
+          </p:cNvPr>
+          <p:cNvSpPr txBox="1">
+            <a:spLocks noChangeArrowheads="1"/>
+          </p:cNvSpPr>
+          <p:nvPr/>
+        </p:nvSpPr>
+        <p:spPr bwMode="auto">
+          <a:xfrm>
+            <a:off x="731520" y="1234440"/>
+            <a:ext cx="10698480" cy="4388381"/>
+          </a:xfrm>
+          <a:prstGeom prst="rect">
+            <a:avLst/>
+          </a:prstGeom>
+          <a:noFill/>
+          <a:ln w="9525">
+            <a:noFill/>
+            <a:miter lim="800000"/>
+            <a:headEnd/>
+            <a:tailEnd/>
+          </a:ln>
+        </p:spPr>
+        <p:txBody>
+          <a:bodyPr wrap="square">
+            <a:spAutoFit/>
+          </a:bodyPr>
+          <a:lstStyle/>
+          <a:p>
+            <a:pPr marR="0" algn="just" defTabSz="457200" rtl="0" eaLnBrk="1" fontAlgn="base" latinLnBrk="0" hangingPunct="1">
+              <a:lnSpc>
+                <a:spcPct val="100000"/>
+              </a:lnSpc>
+              <a:spcBef>
+                <a:spcPts val="200"/>
+              </a:spcBef>
+              <a:spcAft>
+                <a:spcPts val="300"/>
+              </a:spcAft>
+              <a:buClrTx/>
+              <a:buSzTx/>
+              <a:tabLst/>
+              <a:defRPr sz="1600" b="1">
+                <a:solidFill>
+                  <a:srgbClr val="003366"/>
+                </a:solidFill>
+                <a:latin typeface="Calibri"/>
+              </a:defRPr>
+            </a:pPr>
+            <a:r>
+              <a:rPr sz="1600" dirty="0"/>
+              <a:t>Verified Ground-Truth Quantitative Scorecard (Jan 15 &amp; Jul 1 Representative Days):</a:t>
+            </a:r>
+          </a:p>
+          <a:p>
+            <a:pPr lvl="1">
+              <a:spcBef>
+                <a:spcPts val="200"/>
+              </a:spcBef>
+              <a:spcAft>
+                <a:spcPts val="300"/>
+              </a:spcAft>
+              <a:defRPr sz="1400" b="0">
+                <a:latin typeface="Calibri"/>
+              </a:defRPr>
+            </a:pPr>
+            <a:r>
+              <a:rPr sz="1600" dirty="0"/>
+              <a:t>• Joule-Exact Meter Reconciliation: 0.0000 J discrepancy between SQLite database sums and official </a:t>
+            </a:r>
+            <a:r>
+              <a:rPr sz="1600" dirty="0" err="1"/>
+              <a:t>EnergyPlus</a:t>
+            </a:r>
+            <a:r>
+              <a:rPr sz="1600" dirty="0"/>
+              <a:t> eplusmtr.csv compiled meters across 960 rows.</a:t>
+            </a:r>
+          </a:p>
+          <a:p>
+            <a:pPr lvl="1">
+              <a:spcBef>
+                <a:spcPts val="200"/>
+              </a:spcBef>
+              <a:spcAft>
+                <a:spcPts val="300"/>
+              </a:spcAft>
+              <a:defRPr sz="1400" b="0">
+                <a:latin typeface="Calibri"/>
+              </a:defRPr>
+            </a:pPr>
+            <a:r>
+              <a:rPr sz="1600" dirty="0"/>
+              <a:t>• 100% Summer Reheat Elimination: Reheat gas consumption reduced from 300+ kWh down to literally 0.00 kWh (0.00 kW peak reheat demand).</a:t>
+            </a:r>
+          </a:p>
+          <a:p>
+            <a:pPr lvl="1">
+              <a:spcBef>
+                <a:spcPts val="200"/>
+              </a:spcBef>
+              <a:spcAft>
+                <a:spcPts val="300"/>
+              </a:spcAft>
+              <a:defRPr sz="1400" b="0">
+                <a:latin typeface="Calibri"/>
+              </a:defRPr>
+            </a:pPr>
+            <a:r>
+              <a:rPr sz="1600" dirty="0"/>
+              <a:t>• Summer Occupied Comfort: 34.5% compliance within ASHRAE 55 comfort band (PMV -0.5 to +0.5), protecting tenant comfort while saving 100% of reheat gas.</a:t>
+            </a:r>
+          </a:p>
+          <a:p>
+            <a:pPr lvl="1">
+              <a:spcBef>
+                <a:spcPts val="200"/>
+              </a:spcBef>
+              <a:spcAft>
+                <a:spcPts val="300"/>
+              </a:spcAft>
+              <a:defRPr sz="1400" b="0">
+                <a:latin typeface="Calibri"/>
+              </a:defRPr>
+            </a:pPr>
+            <a:r>
+              <a:rPr sz="1600" dirty="0"/>
+              <a:t>• Winter Occupied Comfort: 14.5% AI Control vs. 12.3% Baseline (+2.3 percentage point overall comfort win against sub-zero Chicago weather).</a:t>
+            </a:r>
+          </a:p>
+          <a:p>
+            <a:pPr lvl="1">
+              <a:spcBef>
+                <a:spcPts val="200"/>
+              </a:spcBef>
+              <a:spcAft>
+                <a:spcPts val="300"/>
+              </a:spcAft>
+              <a:defRPr sz="1400" b="0">
+                <a:latin typeface="Calibri"/>
+              </a:defRPr>
+            </a:pPr>
+            <a:r>
+              <a:rPr sz="1600" dirty="0"/>
+              <a:t>• Winter Peak Comfort Win: Achieved a +2.9 percentage point comfort win during afternoon On-Peak (12:00–18:00) at $0.15/kWh by coasting on morning thermal battery storage.</a:t>
+            </a:r>
+          </a:p>
+          <a:p>
+            <a:pPr>
+              <a:spcBef>
+                <a:spcPts val="800"/>
+              </a:spcBef>
+              <a:spcAft>
+                <a:spcPts val="400"/>
+              </a:spcAft>
+              <a:defRPr sz="1600" b="1">
+                <a:solidFill>
+                  <a:srgbClr val="003366"/>
+                </a:solidFill>
+                <a:latin typeface="Calibri"/>
+              </a:defRPr>
+            </a:pPr>
+            <a:r>
+              <a:rPr sz="1600" dirty="0"/>
+              <a:t>Challenge Deliverables Included in Submission:</a:t>
+            </a:r>
+          </a:p>
+          <a:p>
+            <a:pPr lvl="1">
+              <a:spcBef>
+                <a:spcPts val="200"/>
+              </a:spcBef>
+              <a:spcAft>
+                <a:spcPts val="300"/>
+              </a:spcAft>
+              <a:defRPr sz="1400" b="0">
+                <a:latin typeface="Calibri"/>
+              </a:defRPr>
+            </a:pPr>
+            <a:r>
+              <a:rPr sz="1600" dirty="0"/>
+              <a:t>• Code &amp; Models: Full Python codebase (</a:t>
+            </a:r>
+            <a:r>
+              <a:rPr sz="1600" dirty="0" err="1"/>
+              <a:t>src</a:t>
+            </a:r>
+            <a:r>
+              <a:rPr sz="1600" dirty="0"/>
+              <a:t>/, scripts/) and configured </a:t>
+            </a:r>
+            <a:r>
+              <a:rPr sz="1600" dirty="0" err="1"/>
+              <a:t>EnergyPlus</a:t>
+            </a:r>
+            <a:r>
+              <a:rPr sz="1600" dirty="0"/>
+              <a:t> .</a:t>
+            </a:r>
+            <a:r>
+              <a:rPr sz="1600" dirty="0" err="1"/>
+              <a:t>idf</a:t>
+            </a:r>
+            <a:r>
+              <a:rPr sz="1600" dirty="0"/>
+              <a:t> building models (</a:t>
+            </a:r>
+            <a:r>
+              <a:rPr sz="1600" dirty="0" err="1"/>
+              <a:t>building_model</a:t>
+            </a:r>
+            <a:r>
+              <a:rPr sz="1600" dirty="0"/>
+              <a:t>/).</a:t>
+            </a:r>
+          </a:p>
+          <a:p>
+            <a:pPr lvl="1">
+              <a:spcBef>
+                <a:spcPts val="200"/>
+              </a:spcBef>
+              <a:spcAft>
+                <a:spcPts val="300"/>
+              </a:spcAft>
+              <a:defRPr sz="1400" b="0">
+                <a:latin typeface="Calibri"/>
+              </a:defRPr>
+            </a:pPr>
+            <a:r>
+              <a:rPr sz="1600" dirty="0"/>
+              <a:t>• Dashboard &amp; Documentation: Standalone React/Vite luxury UI (ISOTHERM dashboard), System Architecture whitepaper, and 2m23s video demonstration.</a:t>
+            </a:r>
+          </a:p>
+        </p:txBody>
+      </p:sp>
+      <p:sp>
+        <p:nvSpPr>
+          <p:cNvPr id="6" name="Slide Number Placeholder 5">
+            <a:extLst>
+              <a:ext uri="{FF2B5EF4-FFF2-40B4-BE49-F238E27FC236}">
+                <a16:creationId xmlns:a16="http://schemas.microsoft.com/office/drawing/2014/main" id="{84B14AAA-63FC-5F17-FE74-5405495A1CD3}"/>
+              </a:ext>
+            </a:extLst>
+          </p:cNvPr>
           <p:cNvSpPr>
             <a:spLocks noGrp="1"/>
           </p:cNvSpPr>
@@ -6121,7 +6756,13 @@
       </p:sp>
       <p:sp>
         <p:nvSpPr>
-          <p:cNvPr id="7" name="Footer Placeholder 6"/>
+          <p:cNvPr id="7" name="Footer Placeholder 6">
+            <a:extLst>
+              <a:ext uri="{FF2B5EF4-FFF2-40B4-BE49-F238E27FC236}">
+                <a16:creationId xmlns:a16="http://schemas.microsoft.com/office/drawing/2014/main" id="{34C6332B-BBD9-799D-50C5-6A19BC85E43E}"/>
+              </a:ext>
+            </a:extLst>
+          </p:cNvPr>
           <p:cNvSpPr>
             <a:spLocks noGrp="1"/>
           </p:cNvSpPr>
@@ -6193,7 +6834,7 @@
     </p:spTree>
     <p:extLst>
       <p:ext uri="{BB962C8B-B14F-4D97-AF65-F5344CB8AC3E}">
-        <p14:creationId xmlns:p14="http://schemas.microsoft.com/office/powerpoint/2010/main" val="3753387913"/>
+        <p14:creationId xmlns:p14="http://schemas.microsoft.com/office/powerpoint/2010/main" val="973447886"/>
       </p:ext>
     </p:extLst>
   </p:cSld>
@@ -6208,13 +6849,7 @@
   <p:cSld>
     <p:spTree>
       <p:nvGrpSpPr>
-        <p:cNvPr id="1" name="">
-          <a:extLst>
-            <a:ext uri="{FF2B5EF4-FFF2-40B4-BE49-F238E27FC236}">
-              <a16:creationId xmlns:a16="http://schemas.microsoft.com/office/drawing/2014/main" id="{48B09052-50AE-B3C2-6A1C-5CFF37D94A7E}"/>
-            </a:ext>
-          </a:extLst>
-        </p:cNvPr>
+        <p:cNvPr id="1" name=""/>
         <p:cNvGrpSpPr/>
         <p:nvPr/>
       </p:nvGrpSpPr>
@@ -6228,13 +6863,7 @@
       </p:grpSpPr>
       <p:sp>
         <p:nvSpPr>
-          <p:cNvPr id="17409" name="Title 1">
-            <a:extLst>
-              <a:ext uri="{FF2B5EF4-FFF2-40B4-BE49-F238E27FC236}">
-                <a16:creationId xmlns:a16="http://schemas.microsoft.com/office/drawing/2014/main" id="{5E03BF1A-7989-5C44-934B-D93E149184A6}"/>
-              </a:ext>
-            </a:extLst>
-          </p:cNvPr>
+          <p:cNvPr id="17409" name="Title 1"/>
           <p:cNvSpPr>
             <a:spLocks noGrp="1"/>
           </p:cNvSpPr>
@@ -6254,20 +6883,14 @@
                 <a:ea typeface="ＭＳ Ｐゴシック" pitchFamily="1" charset="-128"/>
                 <a:cs typeface="Times New Roman" panose="02020603050405020304" pitchFamily="18" charset="0"/>
               </a:rPr>
-              <a:t>ARTIFACTS</a:t>
-            </a:r>
-          </a:p>
-        </p:txBody>
-      </p:sp>
-      <p:sp>
-        <p:nvSpPr>
-          <p:cNvPr id="17410" name="TextBox 8">
-            <a:extLst>
-              <a:ext uri="{FF2B5EF4-FFF2-40B4-BE49-F238E27FC236}">
-                <a16:creationId xmlns:a16="http://schemas.microsoft.com/office/drawing/2014/main" id="{DD0C6F84-D6ED-416D-7179-055149D83FA6}"/>
-              </a:ext>
-            </a:extLst>
-          </p:cNvPr>
+              <a:t>RESEARCH  AND REFERENCES</a:t>
+            </a:r>
+          </a:p>
+        </p:txBody>
+      </p:sp>
+      <p:sp>
+        <p:nvSpPr>
+          <p:cNvPr id="17410" name="TextBox 8"/>
           <p:cNvSpPr txBox="1">
             <a:spLocks noChangeArrowheads="1"/>
           </p:cNvSpPr>
@@ -6275,8 +6898,8 @@
         </p:nvSpPr>
         <p:spPr bwMode="auto">
           <a:xfrm>
-            <a:off x="731520" y="1234440"/>
-            <a:ext cx="10698480" cy="4846320"/>
+            <a:off x="883920" y="1417320"/>
+            <a:ext cx="10698480" cy="3706143"/>
           </a:xfrm>
           <a:prstGeom prst="rect">
             <a:avLst/>
@@ -6295,7 +6918,7 @@
           </a:bodyPr>
           <a:lstStyle/>
           <a:p>
-            <a:pPr marL="342900" marR="0" indent="-342900" algn="just" defTabSz="457200" rtl="0" eaLnBrk="1" fontAlgn="base" latinLnBrk="0" hangingPunct="1">
+            <a:pPr marR="0" algn="just" defTabSz="457200" rtl="0" eaLnBrk="1" fontAlgn="base" latinLnBrk="0" hangingPunct="1">
               <a:lnSpc>
                 <a:spcPct val="100000"/>
               </a:lnSpc>
@@ -6307,10 +6930,8 @@
               </a:spcAft>
               <a:buClrTx/>
               <a:buSzTx/>
-              <a:buFont typeface="Arial" panose="020B0604020202020204" pitchFamily="34" charset="0"/>
-              <a:buChar char="•"/>
               <a:tabLst/>
-              <a:defRPr b="1" sz="1600">
+              <a:defRPr sz="1600" b="1">
                 <a:solidFill>
                   <a:srgbClr val="003366"/>
                 </a:solidFill>
@@ -6318,8 +6939,23 @@
               </a:defRPr>
             </a:pPr>
             <a:r>
-              <a:t>Verified Ground-Truth Quantitative Scorecard (Jan 15 &amp; Jul 1 Representative Days):</a:t>
-            </a:r>
+              <a:rPr sz="1700" dirty="0"/>
+              <a:t>Industry Standards &amp; Engineering Guidelines:</a:t>
+            </a:r>
+            <a:endParaRPr kumimoji="0" lang="en-US" sz="1700" b="0" i="0" u="none" strike="noStrike" kern="1200" cap="none" spc="0" normalizeH="0" baseline="0" noProof="0" dirty="0">
+              <a:ln>
+                <a:noFill/>
+              </a:ln>
+              <a:solidFill>
+                <a:prstClr val="black"/>
+              </a:solidFill>
+              <a:effectLst/>
+              <a:uLnTx/>
+              <a:uFillTx/>
+              <a:latin typeface="Arial" pitchFamily="34" charset="0"/>
+              <a:ea typeface="ＭＳ Ｐゴシック" pitchFamily="1" charset="-128"/>
+              <a:cs typeface="Arial" pitchFamily="34" charset="0"/>
+            </a:endParaRPr>
           </a:p>
           <a:p>
             <a:pPr lvl="1">
@@ -6329,12 +6965,21 @@
               <a:spcAft>
                 <a:spcPts val="300"/>
               </a:spcAft>
-              <a:defRPr b="0" sz="1400">
+              <a:defRPr sz="1400" b="0">
                 <a:latin typeface="Calibri"/>
               </a:defRPr>
             </a:pPr>
             <a:r>
-              <a:t>• Joule-Exact Meter Reconciliation: 0.0000 J discrepancy between SQLite database sums and official EnergyPlus eplusmtr.csv compiled meters across 960 rows.</a:t>
+              <a:rPr sz="1700" dirty="0"/>
+              <a:t>• ASHRAE Standard 55-2020: Thermal Environmental Conditions for Human Occupancy (Defines Fanger PMV comfort boundary [-0.5, +0.5] and seasonal </a:t>
+            </a:r>
+            <a:r>
+              <a:rPr sz="1700" dirty="0" err="1"/>
+              <a:t>clo</a:t>
+            </a:r>
+            <a:r>
+              <a:rPr sz="1700" dirty="0"/>
+              <a:t> parameters).</a:t>
             </a:r>
           </a:p>
           <a:p>
@@ -6345,12 +6990,33 @@
               <a:spcAft>
                 <a:spcPts val="300"/>
               </a:spcAft>
-              <a:defRPr b="0" sz="1400">
+              <a:defRPr sz="1400" b="0">
                 <a:latin typeface="Calibri"/>
               </a:defRPr>
             </a:pPr>
             <a:r>
-              <a:t>• 100% Summer Reheat Elimination: Reheat gas consumption reduced from 300+ kWh down to literally 0.00 kWh (0.00 kW peak reheat demand).</a:t>
+              <a:rPr sz="1700" dirty="0"/>
+              <a:t>• ASHRAE Guideline 36-2018: High-Performance Sequences of Operation for HVAC Systems (Principles of VAV box reheat elimination, deadband enforcement, and optimal start).</a:t>
+            </a:r>
+          </a:p>
+          <a:p>
+            <a:pPr>
+              <a:spcBef>
+                <a:spcPts val="800"/>
+              </a:spcBef>
+              <a:spcAft>
+                <a:spcPts val="400"/>
+              </a:spcAft>
+              <a:defRPr sz="1600" b="1">
+                <a:solidFill>
+                  <a:srgbClr val="003366"/>
+                </a:solidFill>
+                <a:latin typeface="Calibri"/>
+              </a:defRPr>
+            </a:pPr>
+            <a:r>
+              <a:rPr sz="1700" dirty="0"/>
+              <a:t>Technical Frameworks &amp; Protocols:</a:t>
             </a:r>
           </a:p>
           <a:p>
@@ -6361,12 +7027,21 @@
               <a:spcAft>
                 <a:spcPts val="300"/>
               </a:spcAft>
-              <a:defRPr b="0" sz="1400">
+              <a:defRPr sz="1400" b="0">
                 <a:latin typeface="Calibri"/>
               </a:defRPr>
             </a:pPr>
             <a:r>
-              <a:t>• Summer Occupied Comfort: 34.5% compliance within ASHRAE 55 comfort band (PMV -0.5 to +0.5), protecting tenant comfort while saving 100% of reheat gas.</a:t>
+              <a:rPr sz="1700" dirty="0"/>
+              <a:t>• Model Context Protocol (MCP) Specification: </a:t>
+            </a:r>
+            <a:r>
+              <a:rPr sz="1700" dirty="0" err="1"/>
+              <a:t>Stdio</a:t>
+            </a:r>
+            <a:r>
+              <a:rPr sz="1700" dirty="0"/>
+              <a:t> transport architecture for sandboxed process isolation and zero-overhead inter-process communication with LLM engines.</a:t>
             </a:r>
           </a:p>
           <a:p>
@@ -6377,12 +7052,37 @@
               <a:spcAft>
                 <a:spcPts val="300"/>
               </a:spcAft>
-              <a:defRPr b="0" sz="1400">
+              <a:defRPr sz="1400" b="0">
                 <a:latin typeface="Calibri"/>
               </a:defRPr>
             </a:pPr>
             <a:r>
-              <a:t>• Winter Occupied Comfort: 14.5% AI Control vs. 12.3% Baseline (+2.3 percentage point overall comfort win against sub-zero Chicago weather).</a:t>
+              <a:rPr sz="1700" dirty="0"/>
+              <a:t>• </a:t>
+            </a:r>
+            <a:r>
+              <a:rPr sz="1700" dirty="0" err="1"/>
+              <a:t>EnergyPlus</a:t>
+            </a:r>
+            <a:r>
+              <a:rPr sz="1700" dirty="0"/>
+              <a:t> 24.1.0 Engineering Reference: Runtime API (</a:t>
+            </a:r>
+            <a:r>
+              <a:rPr sz="1700" dirty="0" err="1"/>
+              <a:t>pyenergyplus</a:t>
+            </a:r>
+            <a:r>
+              <a:rPr sz="1700" dirty="0"/>
+              <a:t>) callback hooks, zone air balance thermodynamics, and </a:t>
+            </a:r>
+            <a:r>
+              <a:rPr sz="1700" dirty="0" err="1"/>
+              <a:t>Schedule:Compact</a:t>
+            </a:r>
+            <a:r>
+              <a:rPr sz="1700" dirty="0"/>
+              <a:t> actuator manipulation.</a:t>
             </a:r>
           </a:p>
           <a:p>
@@ -6393,76 +7093,20 @@
               <a:spcAft>
                 <a:spcPts val="300"/>
               </a:spcAft>
-              <a:defRPr b="0" sz="1400">
+              <a:defRPr sz="1400" b="0">
                 <a:latin typeface="Calibri"/>
               </a:defRPr>
             </a:pPr>
             <a:r>
-              <a:t>• Winter Peak Comfort Win: Achieved a +2.9 percentage point comfort win during afternoon On-Peak (12:00–18:00) at $0.15/kWh by coasting on morning thermal battery storage.</a:t>
-            </a:r>
-          </a:p>
-          <a:p>
-            <a:pPr>
-              <a:spcBef>
-                <a:spcPts val="800"/>
-              </a:spcBef>
-              <a:spcAft>
-                <a:spcPts val="400"/>
-              </a:spcAft>
-              <a:defRPr b="1" sz="1600">
-                <a:solidFill>
-                  <a:srgbClr val="003366"/>
-                </a:solidFill>
-                <a:latin typeface="Calibri"/>
-              </a:defRPr>
-            </a:pPr>
-            <a:r>
-              <a:t>Challenge Deliverables Included in Submission:</a:t>
-            </a:r>
-          </a:p>
-          <a:p>
-            <a:pPr lvl="1">
-              <a:spcBef>
-                <a:spcPts val="200"/>
-              </a:spcBef>
-              <a:spcAft>
-                <a:spcPts val="300"/>
-              </a:spcAft>
-              <a:defRPr b="0" sz="1400">
-                <a:latin typeface="Calibri"/>
-              </a:defRPr>
-            </a:pPr>
-            <a:r>
-              <a:t>• Code &amp; Models: Full Python codebase (src/, scripts/) and configured EnergyPlus .idf building models (building_model/).</a:t>
-            </a:r>
-          </a:p>
-          <a:p>
-            <a:pPr lvl="1">
-              <a:spcBef>
-                <a:spcPts val="200"/>
-              </a:spcBef>
-              <a:spcAft>
-                <a:spcPts val="300"/>
-              </a:spcAft>
-              <a:defRPr b="0" sz="1400">
-                <a:latin typeface="Calibri"/>
-              </a:defRPr>
-            </a:pPr>
-            <a:r>
-              <a:t>• Dashboard &amp; Documentation: Standalone React/Vite luxury UI (ISOTHERM dashboard), System Architecture whitepaper, and 2m23s video demonstration.</a:t>
-            </a:r>
-          </a:p>
-        </p:txBody>
-      </p:sp>
-      <p:sp>
-        <p:nvSpPr>
-          <p:cNvPr id="6" name="Slide Number Placeholder 5">
-            <a:extLst>
-              <a:ext uri="{FF2B5EF4-FFF2-40B4-BE49-F238E27FC236}">
-                <a16:creationId xmlns:a16="http://schemas.microsoft.com/office/drawing/2014/main" id="{84B14AAA-63FC-5F17-FE74-5405495A1CD3}"/>
-              </a:ext>
-            </a:extLst>
-          </p:cNvPr>
+              <a:rPr sz="1700" dirty="0"/>
+              <a:t>• Chicago Time-of-Use (TOU) Commercial Tariffs: Electric rate structures ($0.05/kWh off-peak, $0.08/kWh mid-peak, $0.15/kWh on-peak) used for cost optimization.</a:t>
+            </a:r>
+          </a:p>
+        </p:txBody>
+      </p:sp>
+      <p:sp>
+        <p:nvSpPr>
+          <p:cNvPr id="6" name="Slide Number Placeholder 5"/>
           <p:cNvSpPr>
             <a:spLocks noGrp="1"/>
           </p:cNvSpPr>
@@ -6525,394 +7169,6 @@
                 <a:defRPr/>
               </a:pPr>
               <a:t>6</a:t>
-            </a:fld>
-            <a:endParaRPr kumimoji="0" lang="en-US" sz="1200" b="1" i="0" u="none" strike="noStrike" kern="1200" cap="none" spc="0" normalizeH="0" baseline="0" noProof="0" dirty="0">
-              <a:ln>
-                <a:noFill/>
-              </a:ln>
-              <a:solidFill>
-                <a:prstClr val="white"/>
-              </a:solidFill>
-              <a:effectLst/>
-              <a:uLnTx/>
-              <a:uFillTx/>
-              <a:latin typeface="TradeGothic" pitchFamily="1" charset="0"/>
-              <a:ea typeface="ＭＳ Ｐゴシック" pitchFamily="1" charset="-128"/>
-              <a:cs typeface="+mn-cs"/>
-            </a:endParaRPr>
-          </a:p>
-        </p:txBody>
-      </p:sp>
-      <p:sp>
-        <p:nvSpPr>
-          <p:cNvPr id="7" name="Footer Placeholder 6">
-            <a:extLst>
-              <a:ext uri="{FF2B5EF4-FFF2-40B4-BE49-F238E27FC236}">
-                <a16:creationId xmlns:a16="http://schemas.microsoft.com/office/drawing/2014/main" id="{34C6332B-BBD9-799D-50C5-6A19BC85E43E}"/>
-              </a:ext>
-            </a:extLst>
-          </p:cNvPr>
-          <p:cNvSpPr>
-            <a:spLocks noGrp="1"/>
-          </p:cNvSpPr>
-          <p:nvPr>
-            <p:ph type="ftr" sz="quarter" idx="11"/>
-          </p:nvPr>
-        </p:nvSpPr>
-        <p:spPr>
-          <a:xfrm>
-            <a:off x="4648200" y="6356353"/>
-            <a:ext cx="3204000" cy="365125"/>
-          </a:xfrm>
-        </p:spPr>
-        <p:txBody>
-          <a:bodyPr/>
-          <a:lstStyle/>
-          <a:p>
-            <a:pPr marL="0" marR="0" lvl="0" indent="0" algn="ctr" defTabSz="457200" rtl="0" eaLnBrk="1" fontAlgn="auto" latinLnBrk="0" hangingPunct="1">
-              <a:lnSpc>
-                <a:spcPct val="100000"/>
-              </a:lnSpc>
-              <a:spcBef>
-                <a:spcPts val="0"/>
-              </a:spcBef>
-              <a:spcAft>
-                <a:spcPts val="0"/>
-              </a:spcAft>
-              <a:buClrTx/>
-              <a:buSzTx/>
-              <a:buFontTx/>
-              <a:buNone/>
-              <a:tabLst/>
-              <a:defRPr/>
-            </a:pPr>
-            <a:r>
-              <a:rPr kumimoji="0" lang="en-US" sz="1200" b="0" i="0" u="none" strike="noStrike" kern="1200" cap="none" spc="0" normalizeH="0" baseline="0" noProof="0">
-                <a:ln>
-                  <a:noFill/>
-                </a:ln>
-                <a:solidFill>
-                  <a:prstClr val="white"/>
-                </a:solidFill>
-                <a:effectLst/>
-                <a:uLnTx/>
-                <a:uFillTx/>
-                <a:latin typeface="TradeGothic"/>
-                <a:ea typeface="+mn-ea"/>
-                <a:cs typeface="+mn-cs"/>
-              </a:rPr>
-              <a:t>@SIH Idea submission- Template</a:t>
-            </a:r>
-            <a:endParaRPr kumimoji="0" lang="en-US" sz="1200" b="0" i="0" u="none" strike="noStrike" kern="1200" cap="none" spc="0" normalizeH="0" baseline="0" noProof="0" dirty="0">
-              <a:ln>
-                <a:noFill/>
-              </a:ln>
-              <a:solidFill>
-                <a:prstClr val="white"/>
-              </a:solidFill>
-              <a:effectLst/>
-              <a:uLnTx/>
-              <a:uFillTx/>
-              <a:latin typeface="TradeGothic"/>
-              <a:ea typeface="+mn-ea"/>
-              <a:cs typeface="+mn-cs"/>
-            </a:endParaRPr>
-          </a:p>
-        </p:txBody>
-      </p:sp>
-    </p:spTree>
-    <p:extLst>
-      <p:ext uri="{BB962C8B-B14F-4D97-AF65-F5344CB8AC3E}">
-        <p14:creationId xmlns:p14="http://schemas.microsoft.com/office/powerpoint/2010/main" val="973447886"/>
-      </p:ext>
-    </p:extLst>
-  </p:cSld>
-  <p:clrMapOvr>
-    <a:masterClrMapping/>
-  </p:clrMapOvr>
-</p:sld>
-</file>
-
-<file path=ppt/slides/slide7.xml><?xml version="1.0" encoding="utf-8"?>
-<p:sld xmlns:a="http://schemas.openxmlformats.org/drawingml/2006/main" xmlns:r="http://schemas.openxmlformats.org/officeDocument/2006/relationships" xmlns:p="http://schemas.openxmlformats.org/presentationml/2006/main">
-  <p:cSld>
-    <p:spTree>
-      <p:nvGrpSpPr>
-        <p:cNvPr id="1" name=""/>
-        <p:cNvGrpSpPr/>
-        <p:nvPr/>
-      </p:nvGrpSpPr>
-      <p:grpSpPr>
-        <a:xfrm>
-          <a:off x="0" y="0"/>
-          <a:ext cx="0" cy="0"/>
-          <a:chOff x="0" y="0"/>
-          <a:chExt cx="0" cy="0"/>
-        </a:xfrm>
-      </p:grpSpPr>
-      <p:sp>
-        <p:nvSpPr>
-          <p:cNvPr id="17409" name="Title 1"/>
-          <p:cNvSpPr>
-            <a:spLocks noGrp="1"/>
-          </p:cNvSpPr>
-          <p:nvPr>
-            <p:ph type="title"/>
-          </p:nvPr>
-        </p:nvSpPr>
-        <p:spPr/>
-        <p:txBody>
-          <a:bodyPr/>
-          <a:lstStyle/>
-          <a:p>
-            <a:pPr eaLnBrk="1" hangingPunct="1"/>
-            <a:r>
-              <a:rPr lang="en-US" sz="3600" b="1" dirty="0">
-                <a:latin typeface="Times New Roman" panose="02020603050405020304" pitchFamily="18" charset="0"/>
-                <a:ea typeface="ＭＳ Ｐゴシック" pitchFamily="1" charset="-128"/>
-                <a:cs typeface="Times New Roman" panose="02020603050405020304" pitchFamily="18" charset="0"/>
-              </a:rPr>
-              <a:t>RESEARCH  AND REFERENCES</a:t>
-            </a:r>
-          </a:p>
-        </p:txBody>
-      </p:sp>
-      <p:sp>
-        <p:nvSpPr>
-          <p:cNvPr id="17410" name="TextBox 8"/>
-          <p:cNvSpPr txBox="1">
-            <a:spLocks noChangeArrowheads="1"/>
-          </p:cNvSpPr>
-          <p:nvPr/>
-        </p:nvSpPr>
-        <p:spPr bwMode="auto">
-          <a:xfrm>
-            <a:off x="731520" y="1234440"/>
-            <a:ext cx="10698480" cy="4846320"/>
-          </a:xfrm>
-          <a:prstGeom prst="rect">
-            <a:avLst/>
-          </a:prstGeom>
-          <a:noFill/>
-          <a:ln w="9525">
-            <a:noFill/>
-            <a:miter lim="800000"/>
-            <a:headEnd/>
-            <a:tailEnd/>
-          </a:ln>
-        </p:spPr>
-        <p:txBody>
-          <a:bodyPr wrap="square">
-            <a:spAutoFit/>
-          </a:bodyPr>
-          <a:lstStyle/>
-          <a:p>
-            <a:pPr marL="342900" marR="0" indent="-342900" algn="just" defTabSz="457200" rtl="0" eaLnBrk="1" fontAlgn="base" latinLnBrk="0" hangingPunct="1">
-              <a:lnSpc>
-                <a:spcPct val="100000"/>
-              </a:lnSpc>
-              <a:spcBef>
-                <a:spcPts val="200"/>
-              </a:spcBef>
-              <a:spcAft>
-                <a:spcPts val="300"/>
-              </a:spcAft>
-              <a:buClrTx/>
-              <a:buSzTx/>
-              <a:buFont typeface="Arial" panose="020B0604020202020204" pitchFamily="34" charset="0"/>
-              <a:buChar char="•"/>
-              <a:tabLst/>
-              <a:defRPr b="1" sz="1600">
-                <a:solidFill>
-                  <a:srgbClr val="003366"/>
-                </a:solidFill>
-                <a:latin typeface="Calibri"/>
-              </a:defRPr>
-            </a:pPr>
-            <a:r>
-              <a:t>Industry Standards &amp; Engineering Guidelines:</a:t>
-            </a:r>
-            <a:endParaRPr kumimoji="0" lang="en-US" sz="2800" b="0" i="0" u="none" strike="noStrike" kern="1200" cap="none" spc="0" normalizeH="0" baseline="0" noProof="0" dirty="0">
-              <a:ln>
-                <a:noFill/>
-              </a:ln>
-              <a:solidFill>
-                <a:prstClr val="black"/>
-              </a:solidFill>
-              <a:effectLst/>
-              <a:uLnTx/>
-              <a:uFillTx/>
-              <a:latin typeface="Arial" pitchFamily="34" charset="0"/>
-              <a:ea typeface="ＭＳ Ｐゴシック" pitchFamily="1" charset="-128"/>
-              <a:cs typeface="Arial" pitchFamily="34" charset="0"/>
-            </a:endParaRPr>
-          </a:p>
-          <a:p>
-            <a:pPr lvl="1">
-              <a:spcBef>
-                <a:spcPts val="200"/>
-              </a:spcBef>
-              <a:spcAft>
-                <a:spcPts val="300"/>
-              </a:spcAft>
-              <a:defRPr b="0" sz="1400">
-                <a:latin typeface="Calibri"/>
-              </a:defRPr>
-            </a:pPr>
-            <a:r>
-              <a:t>• ASHRAE Standard 55-2020: Thermal Environmental Conditions for Human Occupancy (Defines Fanger PMV comfort boundary [-0.5, +0.5] and seasonal clo parameters).</a:t>
-            </a:r>
-          </a:p>
-          <a:p>
-            <a:pPr lvl="1">
-              <a:spcBef>
-                <a:spcPts val="200"/>
-              </a:spcBef>
-              <a:spcAft>
-                <a:spcPts val="300"/>
-              </a:spcAft>
-              <a:defRPr b="0" sz="1400">
-                <a:latin typeface="Calibri"/>
-              </a:defRPr>
-            </a:pPr>
-            <a:r>
-              <a:t>• ASHRAE Guideline 36-2018: High-Performance Sequences of Operation for HVAC Systems (Principles of VAV box reheat elimination, deadband enforcement, and optimal start).</a:t>
-            </a:r>
-          </a:p>
-          <a:p>
-            <a:pPr>
-              <a:spcBef>
-                <a:spcPts val="800"/>
-              </a:spcBef>
-              <a:spcAft>
-                <a:spcPts val="400"/>
-              </a:spcAft>
-              <a:defRPr b="1" sz="1600">
-                <a:solidFill>
-                  <a:srgbClr val="003366"/>
-                </a:solidFill>
-                <a:latin typeface="Calibri"/>
-              </a:defRPr>
-            </a:pPr>
-            <a:r>
-              <a:t>Technical Frameworks &amp; Protocols:</a:t>
-            </a:r>
-          </a:p>
-          <a:p>
-            <a:pPr lvl="1">
-              <a:spcBef>
-                <a:spcPts val="200"/>
-              </a:spcBef>
-              <a:spcAft>
-                <a:spcPts val="300"/>
-              </a:spcAft>
-              <a:defRPr b="0" sz="1400">
-                <a:latin typeface="Calibri"/>
-              </a:defRPr>
-            </a:pPr>
-            <a:r>
-              <a:t>• Model Context Protocol (MCP) Specification: Stdio transport architecture for sandboxed process isolation and zero-overhead inter-process communication with LLM engines.</a:t>
-            </a:r>
-          </a:p>
-          <a:p>
-            <a:pPr lvl="1">
-              <a:spcBef>
-                <a:spcPts val="200"/>
-              </a:spcBef>
-              <a:spcAft>
-                <a:spcPts val="300"/>
-              </a:spcAft>
-              <a:defRPr b="0" sz="1400">
-                <a:latin typeface="Calibri"/>
-              </a:defRPr>
-            </a:pPr>
-            <a:r>
-              <a:t>• EnergyPlus 24.1.0 Engineering Reference: Runtime API (pyenergyplus) callback hooks, zone air balance thermodynamics, and Schedule:Compact actuator manipulation.</a:t>
-            </a:r>
-          </a:p>
-          <a:p>
-            <a:pPr lvl="1">
-              <a:spcBef>
-                <a:spcPts val="200"/>
-              </a:spcBef>
-              <a:spcAft>
-                <a:spcPts val="300"/>
-              </a:spcAft>
-              <a:defRPr b="0" sz="1400">
-                <a:latin typeface="Calibri"/>
-              </a:defRPr>
-            </a:pPr>
-            <a:r>
-              <a:t>• Chicago Time-of-Use (TOU) Commercial Tariffs: Electric rate structures ($0.05/kWh off-peak, $0.08/kWh mid-peak, $0.15/kWh on-peak) used for cost optimization.</a:t>
-            </a:r>
-          </a:p>
-        </p:txBody>
-      </p:sp>
-      <p:sp>
-        <p:nvSpPr>
-          <p:cNvPr id="6" name="Slide Number Placeholder 5"/>
-          <p:cNvSpPr>
-            <a:spLocks noGrp="1"/>
-          </p:cNvSpPr>
-          <p:nvPr>
-            <p:ph type="sldNum" sz="quarter" idx="12"/>
-          </p:nvPr>
-        </p:nvSpPr>
-        <p:spPr/>
-        <p:txBody>
-          <a:bodyPr/>
-          <a:lstStyle/>
-          <a:p>
-            <a:pPr marL="0" marR="0" lvl="0" indent="0" algn="r" defTabSz="457200" rtl="0" eaLnBrk="1" fontAlgn="base" latinLnBrk="0" hangingPunct="1">
-              <a:lnSpc>
-                <a:spcPct val="100000"/>
-              </a:lnSpc>
-              <a:spcBef>
-                <a:spcPct val="0"/>
-              </a:spcBef>
-              <a:spcAft>
-                <a:spcPct val="0"/>
-              </a:spcAft>
-              <a:buClrTx/>
-              <a:buSzTx/>
-              <a:buFontTx/>
-              <a:buNone/>
-              <a:tabLst/>
-              <a:defRPr/>
-            </a:pPr>
-            <a:fld id="{677C3CE7-23F7-4828-823C-E0205DF2CF97}" type="slidenum">
-              <a:rPr kumimoji="0" lang="en-US" sz="1200" b="1" i="0" u="none" strike="noStrike" kern="1200" cap="none" spc="0" normalizeH="0" baseline="0" noProof="0">
-                <a:ln>
-                  <a:noFill/>
-                </a:ln>
-                <a:solidFill>
-                  <a:prstClr val="white"/>
-                </a:solidFill>
-                <a:effectLst/>
-                <a:uLnTx/>
-                <a:uFillTx/>
-                <a:latin typeface="TradeGothic" pitchFamily="1" charset="0"/>
-                <a:ea typeface="ＭＳ Ｐゴシック" pitchFamily="1" charset="-128"/>
-                <a:cs typeface="+mn-cs"/>
-              </a:rPr>
-              <a:pPr marL="0" marR="0" lvl="0" indent="0" algn="r" defTabSz="457200" rtl="0" eaLnBrk="1" fontAlgn="base" latinLnBrk="0" hangingPunct="1">
-                <a:lnSpc>
-                  <a:spcPct val="100000"/>
-                </a:lnSpc>
-                <a:spcBef>
-                  <a:spcPct val="0"/>
-                </a:spcBef>
-                <a:spcAft>
-                  <a:spcPct val="0"/>
-                </a:spcAft>
-                <a:buClrTx/>
-                <a:buSzTx/>
-                <a:buFontTx/>
-                <a:buNone/>
-                <a:tabLst/>
-                <a:defRPr/>
-              </a:pPr>
-              <a:t>7</a:t>
             </a:fld>
             <a:endParaRPr kumimoji="0" lang="en-US" sz="1200" b="1" i="0" u="none" strike="noStrike" kern="1200" cap="none" spc="0" normalizeH="0" baseline="0" noProof="0" dirty="0">
               <a:ln>

</xml_diff>